<commit_message>
Fix pipeline order, add swimlane and sequence diagram PPTXs
- Fix infographic: swap stages 2/3 to match actual code execution order
  (chaos metrics runs BEFORE classification, not after)
- Add Burnout-Pipeline-Sequence.pptx: single-slide horizontal pipeline
- Add Burnout-Swimlanes.pptx: 3-lane diagram (deterministic/AI/output)
  showing the recalculation loop after agent mutations
- Update 6-slide Pipeline.pptx with corrected order and speaker notes
- Rename slide HTML/PNG files to match new stage numbering
- Add create_sequence_pptx.py and create_swimlane_pptx.py generators
</commit_message>
<xml_diff>
--- a/docs/Burnout-Pipeline.pptx
+++ b/docs/Burnout-Pipeline.pptx
@@ -6,13 +6,13 @@
   </p:sldMasterIdLst>
   <p:sldIdLst>
     <p:sldId id="256" r:id="rId7"/>
-    <p:sldId id="257" r:id="rId8"/>
-    <p:sldId id="258" r:id="rId9"/>
-    <p:sldId id="259" r:id="rId10"/>
-    <p:sldId id="260" r:id="rId11"/>
-    <p:sldId id="261" r:id="rId12"/>
+    <p:sldId id="257" r:id="rId9"/>
+    <p:sldId id="258" r:id="rId10"/>
+    <p:sldId id="259" r:id="rId11"/>
+    <p:sldId id="260" r:id="rId12"/>
+    <p:sldId id="261" r:id="rId13"/>
   </p:sldIdLst>
-  <p:sldSz cx="9144000" cy="5143500" type="screen4x3"/>
+  <p:sldSz cx="12191695" cy="6858000" type="screen4x3"/>
   <p:notesSz cx="6858000" cy="9144000"/>
   <p:defaultTextStyle>
     <a:defPPr>
@@ -110,6 +110,848 @@
     </a:lvl9pPr>
   </p:defaultTextStyle>
 </p:presentation>
+</file>
+
+<file path=ppt/notesMasters/notesMaster1.xml><?xml version="1.0" encoding="utf-8"?>
+<p:notesMaster xmlns:a="http://schemas.openxmlformats.org/drawingml/2006/main" xmlns:p="http://schemas.openxmlformats.org/presentationml/2006/main" xmlns:r="http://schemas.openxmlformats.org/officeDocument/2006/relationships">
+  <p:cSld>
+    <p:bg>
+      <p:bgRef idx="1001">
+        <a:schemeClr val="bg1"/>
+      </p:bgRef>
+    </p:bg>
+    <p:spTree>
+      <p:nvGrpSpPr>
+        <p:cNvPr id="1" name=""/>
+        <p:cNvGrpSpPr/>
+        <p:nvPr/>
+      </p:nvGrpSpPr>
+      <p:grpSpPr>
+        <a:xfrm>
+          <a:off x="0" y="0"/>
+          <a:ext cx="0" cy="0"/>
+          <a:chOff x="0" y="0"/>
+          <a:chExt cx="0" cy="0"/>
+        </a:xfrm>
+      </p:grpSpPr>
+      <p:sp>
+        <p:nvSpPr>
+          <p:cNvPr id="2" name="Header Placeholder 1"/>
+          <p:cNvSpPr>
+            <a:spLocks noGrp="1"/>
+          </p:cNvSpPr>
+          <p:nvPr>
+            <p:ph type="hdr" sz="quarter"/>
+          </p:nvPr>
+        </p:nvSpPr>
+        <p:spPr>
+          <a:xfrm>
+            <a:off x="0" y="0"/>
+            <a:ext cx="2971800" cy="457200"/>
+          </a:xfrm>
+          <a:prstGeom prst="rect">
+            <a:avLst/>
+          </a:prstGeom>
+        </p:spPr>
+        <p:txBody>
+          <a:bodyPr vert="horz" lIns="91440" tIns="45720" rIns="91440" bIns="45720" rtlCol="0"/>
+          <a:lstStyle>
+            <a:lvl1pPr algn="l">
+              <a:defRPr sz="1200"/>
+            </a:lvl1pPr>
+          </a:lstStyle>
+          <a:p>
+            <a:endParaRPr lang="en-US"/>
+          </a:p>
+        </p:txBody>
+      </p:sp>
+      <p:sp>
+        <p:nvSpPr>
+          <p:cNvPr id="3" name="Date Placeholder 2"/>
+          <p:cNvSpPr>
+            <a:spLocks noGrp="1"/>
+          </p:cNvSpPr>
+          <p:nvPr>
+            <p:ph type="dt" idx="1"/>
+          </p:nvPr>
+        </p:nvSpPr>
+        <p:spPr>
+          <a:xfrm>
+            <a:off x="3884613" y="0"/>
+            <a:ext cx="2971800" cy="457200"/>
+          </a:xfrm>
+          <a:prstGeom prst="rect">
+            <a:avLst/>
+          </a:prstGeom>
+        </p:spPr>
+        <p:txBody>
+          <a:bodyPr vert="horz" lIns="91440" tIns="45720" rIns="91440" bIns="45720" rtlCol="0"/>
+          <a:lstStyle>
+            <a:lvl1pPr algn="r">
+              <a:defRPr sz="1200"/>
+            </a:lvl1pPr>
+          </a:lstStyle>
+          <a:p>
+            <a:fld id="{0F89C1C7-3DCD-1040-A9CF-14679D8B5DDD}" type="datetimeFigureOut">
+              <a:rPr lang="en-US" smtClean="0"/>
+              <a:t>10/17/16</a:t>
+            </a:fld>
+            <a:endParaRPr lang="en-US"/>
+          </a:p>
+        </p:txBody>
+      </p:sp>
+      <p:sp>
+        <p:nvSpPr>
+          <p:cNvPr id="4" name="Slide Image Placeholder 3"/>
+          <p:cNvSpPr>
+            <a:spLocks noGrp="1" noRot="1" noChangeAspect="1"/>
+          </p:cNvSpPr>
+          <p:nvPr>
+            <p:ph type="sldImg" idx="2"/>
+          </p:nvPr>
+        </p:nvSpPr>
+        <p:spPr>
+          <a:xfrm>
+            <a:off x="1143000" y="685800"/>
+            <a:ext cx="4572000" cy="3429000"/>
+          </a:xfrm>
+          <a:prstGeom prst="rect">
+            <a:avLst/>
+          </a:prstGeom>
+          <a:noFill/>
+          <a:ln w="12700">
+            <a:solidFill>
+              <a:prstClr val="black"/>
+            </a:solidFill>
+          </a:ln>
+        </p:spPr>
+        <p:txBody>
+          <a:bodyPr vert="horz" lIns="91440" tIns="45720" rIns="91440" bIns="45720" rtlCol="0" anchor="ctr"/>
+          <a:lstStyle/>
+          <a:p>
+            <a:endParaRPr lang="en-US"/>
+          </a:p>
+        </p:txBody>
+      </p:sp>
+      <p:sp>
+        <p:nvSpPr>
+          <p:cNvPr id="5" name="Notes Placeholder 4"/>
+          <p:cNvSpPr>
+            <a:spLocks noGrp="1"/>
+          </p:cNvSpPr>
+          <p:nvPr>
+            <p:ph type="body" sz="quarter" idx="3"/>
+          </p:nvPr>
+        </p:nvSpPr>
+        <p:spPr>
+          <a:xfrm>
+            <a:off x="685800" y="4343400"/>
+            <a:ext cx="5486400" cy="4114800"/>
+          </a:xfrm>
+          <a:prstGeom prst="rect">
+            <a:avLst/>
+          </a:prstGeom>
+        </p:spPr>
+        <p:txBody>
+          <a:bodyPr vert="horz" lIns="91440" tIns="45720" rIns="91440" bIns="45720" rtlCol="0"/>
+          <a:lstStyle/>
+          <a:p>
+            <a:pPr lvl="0"/>
+            <a:r>
+              <a:rPr lang="en-US" smtClean="0"/>
+              <a:t>Click to edit Master text styles</a:t>
+            </a:r>
+          </a:p>
+          <a:p>
+            <a:pPr lvl="1"/>
+            <a:r>
+              <a:rPr lang="en-US" smtClean="0"/>
+              <a:t>Second level</a:t>
+            </a:r>
+          </a:p>
+          <a:p>
+            <a:pPr lvl="2"/>
+            <a:r>
+              <a:rPr lang="en-US" smtClean="0"/>
+              <a:t>Third level</a:t>
+            </a:r>
+          </a:p>
+          <a:p>
+            <a:pPr lvl="3"/>
+            <a:r>
+              <a:rPr lang="en-US" smtClean="0"/>
+              <a:t>Fourth level</a:t>
+            </a:r>
+          </a:p>
+          <a:p>
+            <a:pPr lvl="4"/>
+            <a:r>
+              <a:rPr lang="en-US" smtClean="0"/>
+              <a:t>Fifth level</a:t>
+            </a:r>
+            <a:endParaRPr lang="en-US"/>
+          </a:p>
+        </p:txBody>
+      </p:sp>
+      <p:sp>
+        <p:nvSpPr>
+          <p:cNvPr id="6" name="Footer Placeholder 5"/>
+          <p:cNvSpPr>
+            <a:spLocks noGrp="1"/>
+          </p:cNvSpPr>
+          <p:nvPr>
+            <p:ph type="ftr" sz="quarter" idx="4"/>
+          </p:nvPr>
+        </p:nvSpPr>
+        <p:spPr>
+          <a:xfrm>
+            <a:off x="0" y="8685213"/>
+            <a:ext cx="2971800" cy="457200"/>
+          </a:xfrm>
+          <a:prstGeom prst="rect">
+            <a:avLst/>
+          </a:prstGeom>
+        </p:spPr>
+        <p:txBody>
+          <a:bodyPr vert="horz" lIns="91440" tIns="45720" rIns="91440" bIns="45720" rtlCol="0" anchor="b"/>
+          <a:lstStyle>
+            <a:lvl1pPr algn="l">
+              <a:defRPr sz="1200"/>
+            </a:lvl1pPr>
+          </a:lstStyle>
+          <a:p>
+            <a:endParaRPr lang="en-US"/>
+          </a:p>
+        </p:txBody>
+      </p:sp>
+      <p:sp>
+        <p:nvSpPr>
+          <p:cNvPr id="7" name="Slide Number Placeholder 6"/>
+          <p:cNvSpPr>
+            <a:spLocks noGrp="1"/>
+          </p:cNvSpPr>
+          <p:nvPr>
+            <p:ph type="sldNum" sz="quarter" idx="5"/>
+          </p:nvPr>
+        </p:nvSpPr>
+        <p:spPr>
+          <a:xfrm>
+            <a:off x="3884613" y="8685213"/>
+            <a:ext cx="2971800" cy="457200"/>
+          </a:xfrm>
+          <a:prstGeom prst="rect">
+            <a:avLst/>
+          </a:prstGeom>
+        </p:spPr>
+        <p:txBody>
+          <a:bodyPr vert="horz" lIns="91440" tIns="45720" rIns="91440" bIns="45720" rtlCol="0" anchor="b"/>
+          <a:lstStyle>
+            <a:lvl1pPr algn="r">
+              <a:defRPr sz="1200"/>
+            </a:lvl1pPr>
+          </a:lstStyle>
+          <a:p>
+            <a:fld id="{BB5E49A5-4136-284D-997B-48E1D791AD67}" type="slidenum">
+              <a:rPr lang="en-US" smtClean="0"/>
+              <a:t>‹#›</a:t>
+            </a:fld>
+            <a:endParaRPr lang="en-US"/>
+          </a:p>
+        </p:txBody>
+      </p:sp>
+    </p:spTree>
+    <p:extLst>
+      <p:ext uri="{BB962C8B-B14F-4D97-AF65-F5344CB8AC3E}">
+        <p14:creationId xmlns:p14="http://schemas.microsoft.com/office/powerpoint/2010/main" val="2623252185"/>
+      </p:ext>
+    </p:extLst>
+  </p:cSld>
+  <p:clrMap bg1="lt1" tx1="dk1" bg2="lt2" tx2="dk2" accent1="accent1" accent2="accent2" accent3="accent3" accent4="accent4" accent5="accent5" accent6="accent6" hlink="hlink" folHlink="folHlink"/>
+  <p:notesStyle>
+    <a:lvl1pPr marL="0" algn="l" defTabSz="457200" rtl="0" eaLnBrk="1" latinLnBrk="0" hangingPunct="1">
+      <a:defRPr sz="1200" kern="1200">
+        <a:solidFill>
+          <a:schemeClr val="tx1"/>
+        </a:solidFill>
+        <a:latin typeface="+mn-lt"/>
+        <a:ea typeface="+mn-ea"/>
+        <a:cs typeface="+mn-cs"/>
+      </a:defRPr>
+    </a:lvl1pPr>
+    <a:lvl2pPr marL="457200" algn="l" defTabSz="457200" rtl="0" eaLnBrk="1" latinLnBrk="0" hangingPunct="1">
+      <a:defRPr sz="1200" kern="1200">
+        <a:solidFill>
+          <a:schemeClr val="tx1"/>
+        </a:solidFill>
+        <a:latin typeface="+mn-lt"/>
+        <a:ea typeface="+mn-ea"/>
+        <a:cs typeface="+mn-cs"/>
+      </a:defRPr>
+    </a:lvl2pPr>
+    <a:lvl3pPr marL="914400" algn="l" defTabSz="457200" rtl="0" eaLnBrk="1" latinLnBrk="0" hangingPunct="1">
+      <a:defRPr sz="1200" kern="1200">
+        <a:solidFill>
+          <a:schemeClr val="tx1"/>
+        </a:solidFill>
+        <a:latin typeface="+mn-lt"/>
+        <a:ea typeface="+mn-ea"/>
+        <a:cs typeface="+mn-cs"/>
+      </a:defRPr>
+    </a:lvl3pPr>
+    <a:lvl4pPr marL="1371600" algn="l" defTabSz="457200" rtl="0" eaLnBrk="1" latinLnBrk="0" hangingPunct="1">
+      <a:defRPr sz="1200" kern="1200">
+        <a:solidFill>
+          <a:schemeClr val="tx1"/>
+        </a:solidFill>
+        <a:latin typeface="+mn-lt"/>
+        <a:ea typeface="+mn-ea"/>
+        <a:cs typeface="+mn-cs"/>
+      </a:defRPr>
+    </a:lvl4pPr>
+    <a:lvl5pPr marL="1828800" algn="l" defTabSz="457200" rtl="0" eaLnBrk="1" latinLnBrk="0" hangingPunct="1">
+      <a:defRPr sz="1200" kern="1200">
+        <a:solidFill>
+          <a:schemeClr val="tx1"/>
+        </a:solidFill>
+        <a:latin typeface="+mn-lt"/>
+        <a:ea typeface="+mn-ea"/>
+        <a:cs typeface="+mn-cs"/>
+      </a:defRPr>
+    </a:lvl5pPr>
+    <a:lvl6pPr marL="2286000" algn="l" defTabSz="457200" rtl="0" eaLnBrk="1" latinLnBrk="0" hangingPunct="1">
+      <a:defRPr sz="1200" kern="1200">
+        <a:solidFill>
+          <a:schemeClr val="tx1"/>
+        </a:solidFill>
+        <a:latin typeface="+mn-lt"/>
+        <a:ea typeface="+mn-ea"/>
+        <a:cs typeface="+mn-cs"/>
+      </a:defRPr>
+    </a:lvl6pPr>
+    <a:lvl7pPr marL="2743200" algn="l" defTabSz="457200" rtl="0" eaLnBrk="1" latinLnBrk="0" hangingPunct="1">
+      <a:defRPr sz="1200" kern="1200">
+        <a:solidFill>
+          <a:schemeClr val="tx1"/>
+        </a:solidFill>
+        <a:latin typeface="+mn-lt"/>
+        <a:ea typeface="+mn-ea"/>
+        <a:cs typeface="+mn-cs"/>
+      </a:defRPr>
+    </a:lvl7pPr>
+    <a:lvl8pPr marL="3200400" algn="l" defTabSz="457200" rtl="0" eaLnBrk="1" latinLnBrk="0" hangingPunct="1">
+      <a:defRPr sz="1200" kern="1200">
+        <a:solidFill>
+          <a:schemeClr val="tx1"/>
+        </a:solidFill>
+        <a:latin typeface="+mn-lt"/>
+        <a:ea typeface="+mn-ea"/>
+        <a:cs typeface="+mn-cs"/>
+      </a:defRPr>
+    </a:lvl8pPr>
+    <a:lvl9pPr marL="3657600" algn="l" defTabSz="457200" rtl="0" eaLnBrk="1" latinLnBrk="0" hangingPunct="1">
+      <a:defRPr sz="1200" kern="1200">
+        <a:solidFill>
+          <a:schemeClr val="tx1"/>
+        </a:solidFill>
+        <a:latin typeface="+mn-lt"/>
+        <a:ea typeface="+mn-ea"/>
+        <a:cs typeface="+mn-cs"/>
+      </a:defRPr>
+    </a:lvl9pPr>
+  </p:notesStyle>
+</p:notesMaster>
+</file>
+
+<file path=ppt/notesSlides/notesSlide1.xml><?xml version="1.0" encoding="utf-8"?>
+<p:notes xmlns:a="http://schemas.openxmlformats.org/drawingml/2006/main" xmlns:p="http://schemas.openxmlformats.org/presentationml/2006/main" xmlns:r="http://schemas.openxmlformats.org/officeDocument/2006/relationships">
+  <p:cSld>
+    <p:spTree>
+      <p:nvGrpSpPr>
+        <p:cNvPr id="1" name=""/>
+        <p:cNvGrpSpPr/>
+        <p:nvPr/>
+      </p:nvGrpSpPr>
+      <p:grpSpPr>
+        <a:xfrm>
+          <a:off x="0" y="0"/>
+          <a:ext cx="0" cy="0"/>
+          <a:chOff x="0" y="0"/>
+          <a:chExt cx="0" cy="0"/>
+        </a:xfrm>
+      </p:grpSpPr>
+      <p:sp>
+        <p:nvSpPr>
+          <p:cNvPr id="2" name="Slide Image Placeholder 1"/>
+          <p:cNvSpPr>
+            <a:spLocks noGrp="1"/>
+          </p:cNvSpPr>
+          <p:nvPr>
+            <p:ph type="sldImg" idx="2"/>
+          </p:nvPr>
+        </p:nvSpPr>
+        <p:spPr/>
+      </p:sp>
+      <p:sp>
+        <p:nvSpPr>
+          <p:cNvPr id="3" name="Notes Placeholder 2"/>
+          <p:cNvSpPr>
+            <a:spLocks noGrp="1"/>
+          </p:cNvSpPr>
+          <p:nvPr>
+            <p:ph type="body" idx="3" sz="quarter"/>
+          </p:nvPr>
+        </p:nvSpPr>
+        <p:spPr/>
+        <p:txBody>
+          <a:bodyPr/>
+          <a:lstStyle/>
+          <a:p>
+            <a:r>
+              <a:t>The ingestion stage pulls GitHub issues into a versioned in-memory cache. There are two paths: the MCP tool syncs with a GitHub Bearer token for authenticated access, while the public demo API is rate-limited to one sync per repo every five minutes to stay within GitHub's unauthenticated limits.</a:t>
+            </a:r>
+          </a:p>
+          <a:p/>
+          <a:p>
+            <a:r>
+              <a:t>Each issue is stored as a Java record with nine fields — the key ones for stress analysis are labels, assignees, and the camelCase timestamps createdAt and updatedAt. Using snake_case here silently produces nulls, which is a common gotcha.</a:t>
+            </a:r>
+          </a:p>
+          <a:p/>
+          <a:p>
+            <a:r>
+              <a:t>For demo scenarios, synthetic demo labels like demo:touched-today override real timestamps entirely. This is the golden rule: if any demo label is present on an issue, the system never consults the actual timestamp fields. This lets us reliably reproduce stress scenarios regardless of when the demo is run.</a:t>
+            </a:r>
+          </a:p>
+        </p:txBody>
+      </p:sp>
+      <p:sp>
+        <p:nvSpPr>
+          <p:cNvPr id="4" name="Slide Number Placeholder 3"/>
+          <p:cNvSpPr>
+            <a:spLocks noGrp="1"/>
+          </p:cNvSpPr>
+          <p:nvPr>
+            <p:ph type="sldNum" idx="5" sz="quarter"/>
+          </p:nvPr>
+        </p:nvSpPr>
+        <p:spPr/>
+      </p:sp>
+    </p:spTree>
+  </p:cSld>
+  <p:clrMapOvr>
+    <a:masterClrMapping/>
+  </p:clrMapOvr>
+</p:notes>
+</file>
+
+<file path=ppt/notesSlides/notesSlide2.xml><?xml version="1.0" encoding="utf-8"?>
+<p:notes xmlns:a="http://schemas.openxmlformats.org/drawingml/2006/main" xmlns:p="http://schemas.openxmlformats.org/presentationml/2006/main" xmlns:r="http://schemas.openxmlformats.org/officeDocument/2006/relationships">
+  <p:cSld>
+    <p:spTree>
+      <p:nvGrpSpPr>
+        <p:cNvPr id="1" name=""/>
+        <p:cNvGrpSpPr/>
+        <p:nvPr/>
+      </p:nvGrpSpPr>
+      <p:grpSpPr>
+        <a:xfrm>
+          <a:off x="0" y="0"/>
+          <a:ext cx="0" cy="0"/>
+          <a:chOff x="0" y="0"/>
+          <a:chExt cx="0" cy="0"/>
+        </a:xfrm>
+      </p:grpSpPr>
+      <p:sp>
+        <p:nvSpPr>
+          <p:cNvPr id="2" name="Slide Image Placeholder 1"/>
+          <p:cNvSpPr>
+            <a:spLocks noGrp="1"/>
+          </p:cNvSpPr>
+          <p:nvPr>
+            <p:ph type="sldImg" idx="2"/>
+          </p:nvPr>
+        </p:nvSpPr>
+        <p:spPr/>
+      </p:sp>
+      <p:sp>
+        <p:nvSpPr>
+          <p:cNvPr id="3" name="Notes Placeholder 2"/>
+          <p:cNvSpPr>
+            <a:spLocks noGrp="1"/>
+          </p:cNvSpPr>
+          <p:nvPr>
+            <p:ph type="body" idx="3" sz="quarter"/>
+          </p:nvPr>
+        </p:nvSpPr>
+        <p:spPr/>
+        <p:txBody>
+          <a:bodyPr/>
+          <a:lstStyle/>
+          <a:p>
+            <a:r>
+              <a:t>Chaos metrics run first — before classification and before compliance. The chaos score is a simple additive metric from zero to ten. Five boolean signals each contribute two points: three or more mystery-meat issues without descriptions, three or more unresolved urgents older than 24 hours, six or more issues touched in the last 60 minutes, any after-hours activity, and twelve or more distinct labels across all issues indicating label sprawl.</a:t>
+            </a:r>
+          </a:p>
+          <a:p/>
+          <a:p>
+            <a:r>
+              <a:t>This runs before classification because the chaos score feeds into the WorldState, which needs both chaos AND classification data to compute the stress score.</a:t>
+            </a:r>
+          </a:p>
+          <a:p/>
+          <a:p>
+            <a:r>
+              <a:t>After-hours detection is fully timezone-aware. The checkin page sends the browser's timezone, and the server uses it to determine if updates happened before 9 AM, after 6 PM, or on weekends. For demo scenarios, the demo:after-hours label overrides real timestamps entirely.</a:t>
+            </a:r>
+          </a:p>
+        </p:txBody>
+      </p:sp>
+      <p:sp>
+        <p:nvSpPr>
+          <p:cNvPr id="4" name="Slide Number Placeholder 3"/>
+          <p:cNvSpPr>
+            <a:spLocks noGrp="1"/>
+          </p:cNvSpPr>
+          <p:nvPr>
+            <p:ph type="sldNum" idx="5" sz="quarter"/>
+          </p:nvPr>
+        </p:nvSpPr>
+        <p:spPr/>
+      </p:sp>
+    </p:spTree>
+  </p:cSld>
+  <p:clrMapOvr>
+    <a:masterClrMapping/>
+  </p:clrMapOvr>
+</p:notes>
+</file>
+
+<file path=ppt/notesSlides/notesSlide3.xml><?xml version="1.0" encoding="utf-8"?>
+<p:notes xmlns:a="http://schemas.openxmlformats.org/drawingml/2006/main" xmlns:p="http://schemas.openxmlformats.org/presentationml/2006/main" xmlns:r="http://schemas.openxmlformats.org/officeDocument/2006/relationships">
+  <p:cSld>
+    <p:spTree>
+      <p:nvGrpSpPr>
+        <p:cNvPr id="1" name=""/>
+        <p:cNvGrpSpPr/>
+        <p:nvPr/>
+      </p:nvGrpSpPr>
+      <p:grpSpPr>
+        <a:xfrm>
+          <a:off x="0" y="0"/>
+          <a:ext cx="0" cy="0"/>
+          <a:chOff x="0" y="0"/>
+          <a:chExt cx="0" cy="0"/>
+        </a:xfrm>
+      </p:grpSpPr>
+      <p:sp>
+        <p:nvSpPr>
+          <p:cNvPr id="2" name="Slide Image Placeholder 1"/>
+          <p:cNvSpPr>
+            <a:spLocks noGrp="1"/>
+          </p:cNvSpPr>
+          <p:nvPr>
+            <p:ph type="sldImg" idx="2"/>
+          </p:nvPr>
+        </p:nvSpPr>
+        <p:spPr/>
+      </p:sp>
+      <p:sp>
+        <p:nvSpPr>
+          <p:cNvPr id="3" name="Notes Placeholder 2"/>
+          <p:cNvSpPr>
+            <a:spLocks noGrp="1"/>
+          </p:cNvSpPr>
+          <p:nvPr>
+            <p:ph type="body" idx="3" sz="quarter"/>
+          </p:nvPr>
+        </p:nvSpPr>
+        <p:spPr/>
+        <p:txBody>
+          <a:bodyPr/>
+          <a:lstStyle/>
+          <a:p>
+            <a:r>
+              <a:t>Classification runs inside ComplianceService.analyze(), which is the second call after chaos metrics. Every issue is sorted into exactly one of four buckets using a first-match-wins strategy. Deep work catches anything with priority:critical, security, architecture, or issues estimated over two hours. Quick wins match good-first-issue, trivial, or short tasks with clear scope. Maintenance covers dependencies, documentation, chores, and CI. Everything else falls into deferred.</a:t>
+            </a:r>
+          </a:p>
+          <a:p/>
+          <a:p>
+            <a:r>
+              <a:t>Compliance starts at 100 and deducts points for eight violation types. Critical violations like having multiple deep work items or more than seven active issues cost 25 points each. Warnings like bucket overflow cost 10, and informational issues like a growing deferred backlog cost 5.</a:t>
+            </a:r>
+          </a:p>
+          <a:p/>
+          <a:p>
+            <a:r>
+              <a:t>The 3-3-3 day structure is the core framework: at most one deep work item, three quick wins, and three maintenance tasks — seven active issues maximum. Notably, classification runs a second time inside buildDayPlan() to arrange the sorted issues. Anything beyond the seven active slots is automatically deferred.</a:t>
+            </a:r>
+          </a:p>
+        </p:txBody>
+      </p:sp>
+      <p:sp>
+        <p:nvSpPr>
+          <p:cNvPr id="4" name="Slide Number Placeholder 3"/>
+          <p:cNvSpPr>
+            <a:spLocks noGrp="1"/>
+          </p:cNvSpPr>
+          <p:nvPr>
+            <p:ph type="sldNum" idx="5" sz="quarter"/>
+          </p:nvPr>
+        </p:nvSpPr>
+        <p:spPr/>
+      </p:sp>
+    </p:spTree>
+  </p:cSld>
+  <p:clrMapOvr>
+    <a:masterClrMapping/>
+  </p:clrMapOvr>
+</p:notes>
+</file>
+
+<file path=ppt/notesSlides/notesSlide4.xml><?xml version="1.0" encoding="utf-8"?>
+<p:notes xmlns:a="http://schemas.openxmlformats.org/drawingml/2006/main" xmlns:p="http://schemas.openxmlformats.org/presentationml/2006/main" xmlns:r="http://schemas.openxmlformats.org/officeDocument/2006/relationships">
+  <p:cSld>
+    <p:spTree>
+      <p:nvGrpSpPr>
+        <p:cNvPr id="1" name=""/>
+        <p:cNvGrpSpPr/>
+        <p:nvPr/>
+      </p:nvGrpSpPr>
+      <p:grpSpPr>
+        <a:xfrm>
+          <a:off x="0" y="0"/>
+          <a:ext cx="0" cy="0"/>
+          <a:chOff x="0" y="0"/>
+          <a:chExt cx="0" cy="0"/>
+        </a:xfrm>
+      </p:grpSpPr>
+      <p:sp>
+        <p:nvSpPr>
+          <p:cNvPr id="2" name="Slide Image Placeholder 1"/>
+          <p:cNvSpPr>
+            <a:spLocks noGrp="1"/>
+          </p:cNvSpPr>
+          <p:nvPr>
+            <p:ph type="sldImg" idx="2"/>
+          </p:nvPr>
+        </p:nvSpPr>
+        <p:spPr/>
+      </p:sp>
+      <p:sp>
+        <p:nvSpPr>
+          <p:cNvPr id="3" name="Notes Placeholder 2"/>
+          <p:cNvSpPr>
+            <a:spLocks noGrp="1"/>
+          </p:cNvSpPr>
+          <p:nvPr>
+            <p:ph type="body" idx="3" sz="quarter"/>
+          </p:nvPr>
+        </p:nvSpPr>
+        <p:spPr/>
+        <p:txBody>
+          <a:bodyPr/>
+          <a:lstStyle/>
+          <a:p>
+            <a:r>
+              <a:t>The stress score is the sum of six independently calculated components, each with its own cap. Workload goes up to 40 — it penalises having more than seven assigned issues and having multiple deep work items. Chaos maps the bucket level to 0, 10, 20, or 30 points. Context switching adds three points for each issue touched beyond the first five, up to 15. Clarity adds two points per mystery-meat issue up to 10. Sustained load adds five points per consecutive high-chaos day up to 15. After-hours adds five points per issue updated outside working hours, capped at 10.</a:t>
+            </a:r>
+          </a:p>
+          <a:p/>
+          <a:p>
+            <a:r>
+              <a:t>The total is clamped to 100 and mapped to four stress levels: 70 and above is critical, 50 is high, 30 is moderate, and below 30 is low.</a:t>
+            </a:r>
+          </a:p>
+          <a:p/>
+          <a:p>
+            <a:r>
+              <a:t>All twelve input variables in the world state are individually capped — for example, total assigned issues cap at 15 and deferred at 10. This makes the scoring fully deterministic and prevents any single runaway metric from dominating.</a:t>
+            </a:r>
+          </a:p>
+        </p:txBody>
+      </p:sp>
+      <p:sp>
+        <p:nvSpPr>
+          <p:cNvPr id="4" name="Slide Number Placeholder 3"/>
+          <p:cNvSpPr>
+            <a:spLocks noGrp="1"/>
+          </p:cNvSpPr>
+          <p:nvPr>
+            <p:ph type="sldNum" idx="5" sz="quarter"/>
+          </p:nvPr>
+        </p:nvSpPr>
+        <p:spPr/>
+      </p:sp>
+    </p:spTree>
+  </p:cSld>
+  <p:clrMapOvr>
+    <a:masterClrMapping/>
+  </p:clrMapOvr>
+</p:notes>
+</file>
+
+<file path=ppt/notesSlides/notesSlide5.xml><?xml version="1.0" encoding="utf-8"?>
+<p:notes xmlns:a="http://schemas.openxmlformats.org/drawingml/2006/main" xmlns:p="http://schemas.openxmlformats.org/presentationml/2006/main" xmlns:r="http://schemas.openxmlformats.org/officeDocument/2006/relationships">
+  <p:cSld>
+    <p:spTree>
+      <p:nvGrpSpPr>
+        <p:cNvPr id="1" name=""/>
+        <p:cNvGrpSpPr/>
+        <p:nvPr/>
+      </p:nvGrpSpPr>
+      <p:grpSpPr>
+        <a:xfrm>
+          <a:off x="0" y="0"/>
+          <a:ext cx="0" cy="0"/>
+          <a:chOff x="0" y="0"/>
+          <a:chExt cx="0" cy="0"/>
+        </a:xfrm>
+      </p:grpSpPr>
+      <p:sp>
+        <p:nvSpPr>
+          <p:cNvPr id="2" name="Slide Image Placeholder 1"/>
+          <p:cNvSpPr>
+            <a:spLocks noGrp="1"/>
+          </p:cNvSpPr>
+          <p:nvPr>
+            <p:ph type="sldImg" idx="2"/>
+          </p:nvPr>
+        </p:nvSpPr>
+        <p:spPr/>
+      </p:sp>
+      <p:sp>
+        <p:nvSpPr>
+          <p:cNvPr id="3" name="Notes Placeholder 2"/>
+          <p:cNvSpPr>
+            <a:spLocks noGrp="1"/>
+          </p:cNvSpPr>
+          <p:nvPr>
+            <p:ph type="body" idx="3" sz="quarter"/>
+          </p:nvPr>
+        </p:nvSpPr>
+        <p:spPr/>
+        <p:txBody>
+          <a:bodyPr/>
+          <a:lstStyle/>
+          <a:p>
+            <a:r>
+              <a:t>The AI layer uses LangChain4j's supervisor pattern with Azure OpenAI gpt-4o at temperature 0.3. Five specialised sub-agents each have tool methods that apply GitHub labels: the defer agent marks issues for next sprint, the delegate agent flags items for reassignment, the classify agent sorts issues into the 3-3-3 buckets, the scope agent tags unclear issues as blocked, and the wellness agent can suggest breaks, slow intake, or block calendar time.</a:t>
+            </a:r>
+          </a:p>
+          <a:p/>
+          <a:p>
+            <a:r>
+              <a:t>Protection kicks in automatically when the system detects sustained risk: two or more consecutive high-chaos days, any after-hours activity, a stress score of 70 or above, or more than ten assigned issues. When triggered, the protective AI service generates a supportive intervention message alongside the regular analysis.</a:t>
+            </a:r>
+          </a:p>
+          <a:p/>
+          <a:p>
+            <a:r>
+              <a:t>Every AI feature has a deterministic fallback path. If the LLM is unavailable — whether from dummy credentials, network issues, or expired tokens — all features continue to work with pre-computed responses. The AI explains; it never decides. All metrics are calculated deterministically first.</a:t>
+            </a:r>
+          </a:p>
+        </p:txBody>
+      </p:sp>
+      <p:sp>
+        <p:nvSpPr>
+          <p:cNvPr id="4" name="Slide Number Placeholder 3"/>
+          <p:cNvSpPr>
+            <a:spLocks noGrp="1"/>
+          </p:cNvSpPr>
+          <p:nvPr>
+            <p:ph type="sldNum" idx="5" sz="quarter"/>
+          </p:nvPr>
+        </p:nvSpPr>
+        <p:spPr/>
+      </p:sp>
+    </p:spTree>
+  </p:cSld>
+  <p:clrMapOvr>
+    <a:masterClrMapping/>
+  </p:clrMapOvr>
+</p:notes>
+</file>
+
+<file path=ppt/notesSlides/notesSlide6.xml><?xml version="1.0" encoding="utf-8"?>
+<p:notes xmlns:a="http://schemas.openxmlformats.org/drawingml/2006/main" xmlns:p="http://schemas.openxmlformats.org/presentationml/2006/main" xmlns:r="http://schemas.openxmlformats.org/officeDocument/2006/relationships">
+  <p:cSld>
+    <p:spTree>
+      <p:nvGrpSpPr>
+        <p:cNvPr id="1" name=""/>
+        <p:cNvGrpSpPr/>
+        <p:nvPr/>
+      </p:nvGrpSpPr>
+      <p:grpSpPr>
+        <a:xfrm>
+          <a:off x="0" y="0"/>
+          <a:ext cx="0" cy="0"/>
+          <a:chOff x="0" y="0"/>
+          <a:chExt cx="0" cy="0"/>
+        </a:xfrm>
+      </p:grpSpPr>
+      <p:sp>
+        <p:nvSpPr>
+          <p:cNvPr id="2" name="Slide Image Placeholder 1"/>
+          <p:cNvSpPr>
+            <a:spLocks noGrp="1"/>
+          </p:cNvSpPr>
+          <p:nvPr>
+            <p:ph type="sldImg" idx="2"/>
+          </p:nvPr>
+        </p:nvSpPr>
+        <p:spPr/>
+      </p:sp>
+      <p:sp>
+        <p:nvSpPr>
+          <p:cNvPr id="3" name="Notes Placeholder 2"/>
+          <p:cNvSpPr>
+            <a:spLocks noGrp="1"/>
+          </p:cNvSpPr>
+          <p:nvPr>
+            <p:ph type="body" idx="3" sz="quarter"/>
+          </p:nvPr>
+        </p:nvSpPr>
+        <p:spPr/>
+        <p:txBody>
+          <a:bodyPr/>
+          <a:lstStyle/>
+          <a:p>
+            <a:r>
+              <a:t>The mutation plan is a sealed interface with three action types: add labels, remove labels, and comment. The supervisor agent's tool calls are collected into this plan, which the MCP app then executes against GitHub. Labels like deferred, quick-win, deep-work, 3-3-3, and needs-scope are applied to reshape the developer's workload into the target structure.</a:t>
+            </a:r>
+          </a:p>
+          <a:p/>
+          <a:p>
+            <a:r>
+              <a:t>The Friday deploy score starts at 100 and deducts points for risk factors: 20 points if chaos exceeds 5, another 20 if it exceeds 8, 15 for unresolved urgents, 15 for non-compliance, 10 for after-hours activity, and 10 for more than three mystery-meat issues. The result maps to three statuses: ready at 80 or above, caution from 50 to 79, and not ready below 50.</a:t>
+            </a:r>
+          </a:p>
+          <a:p/>
+          <a:p>
+            <a:r>
+              <a:t>Every stress check-in is persisted as a JPA entity with all six breakdown components, the overall score, stress level, and an optional self-reported score and note. This powers the study dashboard's trend charts, letting researchers track how individual participants' stress evolves over time across multiple check-ins.</a:t>
+            </a:r>
+          </a:p>
+        </p:txBody>
+      </p:sp>
+      <p:sp>
+        <p:nvSpPr>
+          <p:cNvPr id="4" name="Slide Number Placeholder 3"/>
+          <p:cNvSpPr>
+            <a:spLocks noGrp="1"/>
+          </p:cNvSpPr>
+          <p:nvPr>
+            <p:ph type="sldNum" idx="5" sz="quarter"/>
+          </p:nvPr>
+        </p:nvSpPr>
+        <p:spPr/>
+      </p:sp>
+    </p:spTree>
+  </p:cSld>
+  <p:clrMapOvr>
+    <a:masterClrMapping/>
+  </p:clrMapOvr>
+</p:notes>
 </file>
 
 <file path=ppt/slideLayouts/slideLayout1.xml><?xml version="1.0" encoding="utf-8"?>
@@ -3109,8 +3951,8 @@
         </p:nvSpPr>
         <p:spPr>
           <a:xfrm>
-            <a:off x="731520" y="640080"/>
-            <a:ext cx="7680960" cy="365760"/>
+            <a:off x="1097280" y="502920"/>
+            <a:ext cx="9997135" cy="320040"/>
           </a:xfrm>
           <a:prstGeom prst="rect">
             <a:avLst/>
@@ -3127,7 +3969,7 @@
               <a:spcAft>
                 <a:spcPts val="0"/>
               </a:spcAft>
-              <a:defRPr sz="1600" b="1">
+              <a:defRPr sz="1400" b="1">
                 <a:solidFill>
                   <a:srgbClr val="3B82F6"/>
                 </a:solidFill>
@@ -3148,8 +3990,8 @@
         </p:nvSpPr>
         <p:spPr>
           <a:xfrm>
-            <a:off x="731520" y="1005840"/>
-            <a:ext cx="7680960" cy="731520"/>
+            <a:off x="1097280" y="822960"/>
+            <a:ext cx="9997135" cy="594360"/>
           </a:xfrm>
           <a:prstGeom prst="rect">
             <a:avLst/>
@@ -3166,7 +4008,7 @@
               <a:spcAft>
                 <a:spcPts val="0"/>
               </a:spcAft>
-              <a:defRPr sz="4000" b="1">
+              <a:defRPr sz="3600" b="1">
                 <a:solidFill>
                   <a:srgbClr val="F8FAFC"/>
                 </a:solidFill>
@@ -3187,8 +4029,8 @@
         </p:nvSpPr>
         <p:spPr>
           <a:xfrm>
-            <a:off x="1371600" y="2103120"/>
-            <a:ext cx="6858000" cy="411480"/>
+            <a:off x="1463040" y="1828800"/>
+            <a:ext cx="9265615" cy="2926080"/>
           </a:xfrm>
           <a:prstGeom prst="rect">
             <a:avLst/>
@@ -3202,10 +4044,13 @@
           <a:lstStyle/>
           <a:p>
             <a:pPr>
+              <a:spcBef>
+                <a:spcPts val="0"/>
+              </a:spcBef>
               <a:spcAft>
                 <a:spcPts val="200"/>
               </a:spcAft>
-              <a:defRPr sz="2200" b="1">
+              <a:defRPr sz="2000" b="1">
                 <a:solidFill>
                   <a:srgbClr val="F8FAFC"/>
                 </a:solidFill>
@@ -3216,35 +4061,12 @@
               <a:t>GitHub Issues → In-Memory Cache</a:t>
             </a:r>
           </a:p>
-        </p:txBody>
-      </p:sp>
-      <p:sp>
-        <p:nvSpPr>
-          <p:cNvPr id="5" name="TextBox 4"/>
-          <p:cNvSpPr txBox="1"/>
-          <p:nvPr/>
-        </p:nvSpPr>
-        <p:spPr>
-          <a:xfrm>
-            <a:off x="1371600" y="2487168"/>
-            <a:ext cx="6858000" cy="731520"/>
-          </a:xfrm>
-          <a:prstGeom prst="rect">
-            <a:avLst/>
-          </a:prstGeom>
-          <a:noFill/>
-        </p:spPr>
-        <p:txBody>
-          <a:bodyPr wrap="square">
-            <a:spAutoFit/>
-          </a:bodyPr>
-          <a:lstStyle/>
           <a:p>
             <a:pPr>
               <a:spcAft>
                 <a:spcPts val="0"/>
               </a:spcAft>
-              <a:defRPr sz="1600">
+              <a:defRPr sz="1400">
                 <a:solidFill>
                   <a:srgbClr val="94A3B8"/>
                 </a:solidFill>
@@ -3252,38 +4074,18 @@
               </a:defRPr>
             </a:pPr>
             <a:r>
-              <a:t>Issues synced via MCP (authenticated) or public API (rate-limited: 1 per repo per 5 min)</a:t>
-            </a:r>
-          </a:p>
-        </p:txBody>
-      </p:sp>
-      <p:sp>
-        <p:nvSpPr>
-          <p:cNvPr id="6" name="TextBox 5"/>
-          <p:cNvSpPr txBox="1"/>
-          <p:nvPr/>
-        </p:nvSpPr>
-        <p:spPr>
-          <a:xfrm>
-            <a:off x="1371600" y="3474720"/>
-            <a:ext cx="6858000" cy="411480"/>
-          </a:xfrm>
-          <a:prstGeom prst="rect">
-            <a:avLst/>
-          </a:prstGeom>
-          <a:noFill/>
-        </p:spPr>
-        <p:txBody>
-          <a:bodyPr wrap="square">
-            <a:spAutoFit/>
-          </a:bodyPr>
-          <a:lstStyle/>
+              <a:t>Issues synced via MCP or public API (1 per repo per 5 min)</a:t>
+            </a:r>
+          </a:p>
           <a:p>
             <a:pPr>
+              <a:spcBef>
+                <a:spcPts val="1800"/>
+              </a:spcBef>
               <a:spcAft>
                 <a:spcPts val="200"/>
               </a:spcAft>
-              <a:defRPr sz="2200" b="1">
+              <a:defRPr sz="2000" b="1">
                 <a:solidFill>
                   <a:srgbClr val="F8FAFC"/>
                 </a:solidFill>
@@ -3294,35 +4096,12 @@
               <a:t>9 Fields Per Issue</a:t>
             </a:r>
           </a:p>
-        </p:txBody>
-      </p:sp>
-      <p:sp>
-        <p:nvSpPr>
-          <p:cNvPr id="7" name="TextBox 6"/>
-          <p:cNvSpPr txBox="1"/>
-          <p:nvPr/>
-        </p:nvSpPr>
-        <p:spPr>
-          <a:xfrm>
-            <a:off x="1371600" y="3858768"/>
-            <a:ext cx="6858000" cy="731520"/>
-          </a:xfrm>
-          <a:prstGeom prst="rect">
-            <a:avLst/>
-          </a:prstGeom>
-          <a:noFill/>
-        </p:spPr>
-        <p:txBody>
-          <a:bodyPr wrap="square">
-            <a:spAutoFit/>
-          </a:bodyPr>
-          <a:lstStyle/>
           <a:p>
             <a:pPr>
               <a:spcAft>
                 <a:spcPts val="0"/>
               </a:spcAft>
-              <a:defRPr sz="1600">
+              <a:defRPr sz="1400">
                 <a:solidFill>
                   <a:srgbClr val="94A3B8"/>
                 </a:solidFill>
@@ -3333,35 +4112,15 @@
               <a:t>number, title, body, labels, assignees, createdAt, updatedAt, state, milestone</a:t>
             </a:r>
           </a:p>
-        </p:txBody>
-      </p:sp>
-      <p:sp>
-        <p:nvSpPr>
-          <p:cNvPr id="8" name="TextBox 7"/>
-          <p:cNvSpPr txBox="1"/>
-          <p:nvPr/>
-        </p:nvSpPr>
-        <p:spPr>
-          <a:xfrm>
-            <a:off x="1371600" y="4846320"/>
-            <a:ext cx="6858000" cy="411480"/>
-          </a:xfrm>
-          <a:prstGeom prst="rect">
-            <a:avLst/>
-          </a:prstGeom>
-          <a:noFill/>
-        </p:spPr>
-        <p:txBody>
-          <a:bodyPr wrap="square">
-            <a:spAutoFit/>
-          </a:bodyPr>
-          <a:lstStyle/>
           <a:p>
             <a:pPr>
+              <a:spcBef>
+                <a:spcPts val="1800"/>
+              </a:spcBef>
               <a:spcAft>
                 <a:spcPts val="200"/>
               </a:spcAft>
-              <a:defRPr sz="2200" b="1">
+              <a:defRPr sz="2000" b="1">
                 <a:solidFill>
                   <a:srgbClr val="F8FAFC"/>
                 </a:solidFill>
@@ -3369,38 +4128,15 @@
               </a:defRPr>
             </a:pPr>
             <a:r>
-              <a:t>Demo Labels Override Real Timestamps</a:t>
-            </a:r>
-          </a:p>
-        </p:txBody>
-      </p:sp>
-      <p:sp>
-        <p:nvSpPr>
-          <p:cNvPr id="9" name="TextBox 8"/>
-          <p:cNvSpPr txBox="1"/>
-          <p:nvPr/>
-        </p:nvSpPr>
-        <p:spPr>
-          <a:xfrm>
-            <a:off x="1371600" y="5230368"/>
-            <a:ext cx="6858000" cy="731520"/>
-          </a:xfrm>
-          <a:prstGeom prst="rect">
-            <a:avLst/>
-          </a:prstGeom>
-          <a:noFill/>
-        </p:spPr>
-        <p:txBody>
-          <a:bodyPr wrap="square">
-            <a:spAutoFit/>
-          </a:bodyPr>
-          <a:lstStyle/>
+              <a:t>Demo Labels Override Timestamps</a:t>
+            </a:r>
+          </a:p>
           <a:p>
             <a:pPr>
               <a:spcAft>
                 <a:spcPts val="0"/>
               </a:spcAft>
-              <a:defRPr sz="1600">
+              <a:defRPr sz="1400">
                 <a:solidFill>
                   <a:srgbClr val="94A3B8"/>
                 </a:solidFill>
@@ -3408,7 +4144,7 @@
               </a:defRPr>
             </a:pPr>
             <a:r>
-              <a:t>demo:touched-today, demo:after-hours, demo:stale-14d — if present, real timestamps are ignored</a:t>
+              <a:t>demo:touched-today, demo:after-hours, demo:stale-14d</a:t>
             </a:r>
           </a:p>
         </p:txBody>
@@ -3447,8 +4183,8 @@
         </p:nvSpPr>
         <p:spPr>
           <a:xfrm>
-            <a:off x="731520" y="640080"/>
-            <a:ext cx="7680960" cy="365760"/>
+            <a:off x="1097280" y="502920"/>
+            <a:ext cx="9997135" cy="320040"/>
           </a:xfrm>
           <a:prstGeom prst="rect">
             <a:avLst/>
@@ -3465,7 +4201,7 @@
               <a:spcAft>
                 <a:spcPts val="0"/>
               </a:spcAft>
-              <a:defRPr sz="1600" b="1">
+              <a:defRPr sz="1400" b="1">
                 <a:solidFill>
                   <a:srgbClr val="A78BFA"/>
                 </a:solidFill>
@@ -3486,8 +4222,8 @@
         </p:nvSpPr>
         <p:spPr>
           <a:xfrm>
-            <a:off x="731520" y="1005840"/>
-            <a:ext cx="7680960" cy="731520"/>
+            <a:off x="1097280" y="822960"/>
+            <a:ext cx="9997135" cy="594360"/>
           </a:xfrm>
           <a:prstGeom prst="rect">
             <a:avLst/>
@@ -3504,7 +4240,7 @@
               <a:spcAft>
                 <a:spcPts val="0"/>
               </a:spcAft>
-              <a:defRPr sz="4000" b="1">
+              <a:defRPr sz="3600" b="1">
                 <a:solidFill>
                   <a:srgbClr val="F8FAFC"/>
                 </a:solidFill>
@@ -3512,7 +4248,7 @@
               </a:defRPr>
             </a:pPr>
             <a:r>
-              <a:t>Classification</a:t>
+              <a:t>Chaos Metrics</a:t>
             </a:r>
           </a:p>
         </p:txBody>
@@ -3525,8 +4261,8 @@
         </p:nvSpPr>
         <p:spPr>
           <a:xfrm>
-            <a:off x="1371600" y="2103120"/>
-            <a:ext cx="6858000" cy="411480"/>
+            <a:off x="1463040" y="1828800"/>
+            <a:ext cx="9265615" cy="2926080"/>
           </a:xfrm>
           <a:prstGeom prst="rect">
             <a:avLst/>
@@ -3540,10 +4276,13 @@
           <a:lstStyle/>
           <a:p>
             <a:pPr>
+              <a:spcBef>
+                <a:spcPts val="0"/>
+              </a:spcBef>
               <a:spcAft>
                 <a:spcPts val="200"/>
               </a:spcAft>
-              <a:defRPr sz="2200" b="1">
+              <a:defRPr sz="2000" b="1">
                 <a:solidFill>
                   <a:srgbClr val="F8FAFC"/>
                 </a:solidFill>
@@ -3551,38 +4290,15 @@
               </a:defRPr>
             </a:pPr>
             <a:r>
-              <a:t>4 Buckets — First Match Wins</a:t>
-            </a:r>
-          </a:p>
-        </p:txBody>
-      </p:sp>
-      <p:sp>
-        <p:nvSpPr>
-          <p:cNvPr id="5" name="TextBox 4"/>
-          <p:cNvSpPr txBox="1"/>
-          <p:nvPr/>
-        </p:nvSpPr>
-        <p:spPr>
-          <a:xfrm>
-            <a:off x="1371600" y="2487168"/>
-            <a:ext cx="6858000" cy="731520"/>
-          </a:xfrm>
-          <a:prstGeom prst="rect">
-            <a:avLst/>
-          </a:prstGeom>
-          <a:noFill/>
-        </p:spPr>
-        <p:txBody>
-          <a:bodyPr wrap="square">
-            <a:spAutoFit/>
-          </a:bodyPr>
-          <a:lstStyle/>
+              <a:t>Chaos Score 0–10 (5 signals × 2 pts)</a:t>
+            </a:r>
+          </a:p>
           <a:p>
             <a:pPr>
               <a:spcAft>
                 <a:spcPts val="0"/>
               </a:spcAft>
-              <a:defRPr sz="1600">
+              <a:defRPr sz="1400">
                 <a:solidFill>
                   <a:srgbClr val="94A3B8"/>
                 </a:solidFill>
@@ -3590,38 +4306,18 @@
               </a:defRPr>
             </a:pPr>
             <a:r>
-              <a:t>DEEP_WORK (critical, security, architecture) → QUICK_WIN (good-first-issue, trivial) → MAINTENANCE (dependencies, docs, chore) → DEFERRED (default)</a:t>
-            </a:r>
-          </a:p>
-        </p:txBody>
-      </p:sp>
-      <p:sp>
-        <p:nvSpPr>
-          <p:cNvPr id="6" name="TextBox 5"/>
-          <p:cNvSpPr txBox="1"/>
-          <p:nvPr/>
-        </p:nvSpPr>
-        <p:spPr>
-          <a:xfrm>
-            <a:off x="1371600" y="3474720"/>
-            <a:ext cx="6858000" cy="411480"/>
-          </a:xfrm>
-          <a:prstGeom prst="rect">
-            <a:avLst/>
-          </a:prstGeom>
-          <a:noFill/>
-        </p:spPr>
-        <p:txBody>
-          <a:bodyPr wrap="square">
-            <a:spAutoFit/>
-          </a:bodyPr>
-          <a:lstStyle/>
+              <a:t>mystery meat, urgent, context switching, after-hours, label sprawl</a:t>
+            </a:r>
+          </a:p>
           <a:p>
             <a:pPr>
+              <a:spcBef>
+                <a:spcPts val="1800"/>
+              </a:spcBef>
               <a:spcAft>
                 <a:spcPts val="200"/>
               </a:spcAft>
-              <a:defRPr sz="2200" b="1">
+              <a:defRPr sz="2000" b="1">
                 <a:solidFill>
                   <a:srgbClr val="F8FAFC"/>
                 </a:solidFill>
@@ -3629,38 +4325,15 @@
               </a:defRPr>
             </a:pPr>
             <a:r>
-              <a:t>Hour Estimation from Labels &amp; Body</a:t>
-            </a:r>
-          </a:p>
-        </p:txBody>
-      </p:sp>
-      <p:sp>
-        <p:nvSpPr>
-          <p:cNvPr id="7" name="TextBox 6"/>
-          <p:cNvSpPr txBox="1"/>
-          <p:nvPr/>
-        </p:nvSpPr>
-        <p:spPr>
-          <a:xfrm>
-            <a:off x="1371600" y="3858768"/>
-            <a:ext cx="6858000" cy="731520"/>
-          </a:xfrm>
-          <a:prstGeom prst="rect">
-            <a:avLst/>
-          </a:prstGeom>
-          <a:noFill/>
-        </p:spPr>
-        <p:txBody>
-          <a:bodyPr wrap="square">
-            <a:spAutoFit/>
-          </a:bodyPr>
-          <a:lstStyle/>
+              <a:t>Runs BEFORE Classification</a:t>
+            </a:r>
+          </a:p>
           <a:p>
             <a:pPr>
               <a:spcAft>
                 <a:spcPts val="0"/>
               </a:spcAft>
-              <a:defRPr sz="1600">
+              <a:defRPr sz="1400">
                 <a:solidFill>
                   <a:srgbClr val="94A3B8"/>
                 </a:solidFill>
@@ -3668,38 +4341,18 @@
               </a:defRPr>
             </a:pPr>
             <a:r>
-              <a:t>size:s → 0.5h, size:m → 2h, size:l → 4h, size:xl → 8h; body length heuristic as fallback</a:t>
-            </a:r>
-          </a:p>
-        </p:txBody>
-      </p:sp>
-      <p:sp>
-        <p:nvSpPr>
-          <p:cNvPr id="8" name="TextBox 7"/>
-          <p:cNvSpPr txBox="1"/>
-          <p:nvPr/>
-        </p:nvSpPr>
-        <p:spPr>
-          <a:xfrm>
-            <a:off x="1371600" y="4846320"/>
-            <a:ext cx="6858000" cy="411480"/>
-          </a:xfrm>
-          <a:prstGeom prst="rect">
-            <a:avLst/>
-          </a:prstGeom>
-          <a:noFill/>
-        </p:spPr>
-        <p:txBody>
-          <a:bodyPr wrap="square">
-            <a:spAutoFit/>
-          </a:bodyPr>
-          <a:lstStyle/>
+              <a:t>ChaosMetricsService.calculate() is the first call after loading issues</a:t>
+            </a:r>
+          </a:p>
           <a:p>
             <a:pPr>
+              <a:spcBef>
+                <a:spcPts val="1800"/>
+              </a:spcBef>
               <a:spcAft>
                 <a:spcPts val="200"/>
               </a:spcAft>
-              <a:defRPr sz="2200" b="1">
+              <a:defRPr sz="2000" b="1">
                 <a:solidFill>
                   <a:srgbClr val="F8FAFC"/>
                 </a:solidFill>
@@ -3707,38 +4360,15 @@
               </a:defRPr>
             </a:pPr>
             <a:r>
-              <a:t>3-3-3 Day Structure</a:t>
-            </a:r>
-          </a:p>
-        </p:txBody>
-      </p:sp>
-      <p:sp>
-        <p:nvSpPr>
-          <p:cNvPr id="9" name="TextBox 8"/>
-          <p:cNvSpPr txBox="1"/>
-          <p:nvPr/>
-        </p:nvSpPr>
-        <p:spPr>
-          <a:xfrm>
-            <a:off x="1371600" y="5230368"/>
-            <a:ext cx="6858000" cy="731520"/>
-          </a:xfrm>
-          <a:prstGeom prst="rect">
-            <a:avLst/>
-          </a:prstGeom>
-          <a:noFill/>
-        </p:spPr>
-        <p:txBody>
-          <a:bodyPr wrap="square">
-            <a:spAutoFit/>
-          </a:bodyPr>
-          <a:lstStyle/>
+              <a:t>Timezone-Aware After-Hours Detection</a:t>
+            </a:r>
+          </a:p>
           <a:p>
             <a:pPr>
               <a:spcAft>
                 <a:spcPts val="0"/>
               </a:spcAft>
-              <a:defRPr sz="1600">
+              <a:defRPr sz="1400">
                 <a:solidFill>
                   <a:srgbClr val="94A3B8"/>
                 </a:solidFill>
@@ -3746,7 +4376,7 @@
               </a:defRPr>
             </a:pPr>
             <a:r>
-              <a:t>1 deep work + 3 quick wins + 3 maintenance = 7 active max — everything else is deferred</a:t>
+              <a:t>Working hours: 9 AM – 6 PM; weekends always count</a:t>
             </a:r>
           </a:p>
         </p:txBody>
@@ -3785,8 +4415,8 @@
         </p:nvSpPr>
         <p:spPr>
           <a:xfrm>
-            <a:off x="731520" y="640080"/>
-            <a:ext cx="7680960" cy="365760"/>
+            <a:off x="1097280" y="502920"/>
+            <a:ext cx="9997135" cy="320040"/>
           </a:xfrm>
           <a:prstGeom prst="rect">
             <a:avLst/>
@@ -3803,7 +4433,7 @@
               <a:spcAft>
                 <a:spcPts val="0"/>
               </a:spcAft>
-              <a:defRPr sz="1600" b="1">
+              <a:defRPr sz="1400" b="1">
                 <a:solidFill>
                   <a:srgbClr val="F59E0B"/>
                 </a:solidFill>
@@ -3824,8 +4454,8 @@
         </p:nvSpPr>
         <p:spPr>
           <a:xfrm>
-            <a:off x="731520" y="1005840"/>
-            <a:ext cx="7680960" cy="731520"/>
+            <a:off x="1097280" y="822960"/>
+            <a:ext cx="9997135" cy="594360"/>
           </a:xfrm>
           <a:prstGeom prst="rect">
             <a:avLst/>
@@ -3842,7 +4472,7 @@
               <a:spcAft>
                 <a:spcPts val="0"/>
               </a:spcAft>
-              <a:defRPr sz="4000" b="1">
+              <a:defRPr sz="3600" b="1">
                 <a:solidFill>
                   <a:srgbClr val="F8FAFC"/>
                 </a:solidFill>
@@ -3850,7 +4480,7 @@
               </a:defRPr>
             </a:pPr>
             <a:r>
-              <a:t>Metrics &amp; Compliance</a:t>
+              <a:t>Classification &amp; Compliance</a:t>
             </a:r>
           </a:p>
         </p:txBody>
@@ -3863,8 +4493,8 @@
         </p:nvSpPr>
         <p:spPr>
           <a:xfrm>
-            <a:off x="1371600" y="2103120"/>
-            <a:ext cx="6858000" cy="411480"/>
+            <a:off x="1463040" y="1828800"/>
+            <a:ext cx="9265615" cy="2926080"/>
           </a:xfrm>
           <a:prstGeom prst="rect">
             <a:avLst/>
@@ -3878,10 +4508,13 @@
           <a:lstStyle/>
           <a:p>
             <a:pPr>
+              <a:spcBef>
+                <a:spcPts val="0"/>
+              </a:spcBef>
               <a:spcAft>
                 <a:spcPts val="200"/>
               </a:spcAft>
-              <a:defRPr sz="2200" b="1">
+              <a:defRPr sz="2000" b="1">
                 <a:solidFill>
                   <a:srgbClr val="F8FAFC"/>
                 </a:solidFill>
@@ -3889,38 +4522,15 @@
               </a:defRPr>
             </a:pPr>
             <a:r>
-              <a:t>Chaos Score 0–10 (5 signals × 2 pts each)</a:t>
-            </a:r>
-          </a:p>
-        </p:txBody>
-      </p:sp>
-      <p:sp>
-        <p:nvSpPr>
-          <p:cNvPr id="5" name="TextBox 4"/>
-          <p:cNvSpPr txBox="1"/>
-          <p:nvPr/>
-        </p:nvSpPr>
-        <p:spPr>
-          <a:xfrm>
-            <a:off x="1371600" y="2487168"/>
-            <a:ext cx="6858000" cy="731520"/>
-          </a:xfrm>
-          <a:prstGeom prst="rect">
-            <a:avLst/>
-          </a:prstGeom>
-          <a:noFill/>
-        </p:spPr>
-        <p:txBody>
-          <a:bodyPr wrap="square">
-            <a:spAutoFit/>
-          </a:bodyPr>
-          <a:lstStyle/>
+              <a:t>4 Buckets — First Match Wins</a:t>
+            </a:r>
+          </a:p>
           <a:p>
             <a:pPr>
               <a:spcAft>
                 <a:spcPts val="0"/>
               </a:spcAft>
-              <a:defRPr sz="1600">
+              <a:defRPr sz="1400">
                 <a:solidFill>
                   <a:srgbClr val="94A3B8"/>
                 </a:solidFill>
@@ -3928,38 +4538,18 @@
               </a:defRPr>
             </a:pPr>
             <a:r>
-              <a:t>mystery meat ≥ 3, urgent ≥ 3, context switching ≥ 6, after-hours activity, label sprawl ≥ 12</a:t>
-            </a:r>
-          </a:p>
-        </p:txBody>
-      </p:sp>
-      <p:sp>
-        <p:nvSpPr>
-          <p:cNvPr id="6" name="TextBox 5"/>
-          <p:cNvSpPr txBox="1"/>
-          <p:nvPr/>
-        </p:nvSpPr>
-        <p:spPr>
-          <a:xfrm>
-            <a:off x="1371600" y="3474720"/>
-            <a:ext cx="6858000" cy="411480"/>
-          </a:xfrm>
-          <a:prstGeom prst="rect">
-            <a:avLst/>
-          </a:prstGeom>
-          <a:noFill/>
-        </p:spPr>
-        <p:txBody>
-          <a:bodyPr wrap="square">
-            <a:spAutoFit/>
-          </a:bodyPr>
-          <a:lstStyle/>
+              <a:t>DEEP_WORK → QUICK_WIN → MAINTENANCE → DEFERRED</a:t>
+            </a:r>
+          </a:p>
           <a:p>
             <a:pPr>
+              <a:spcBef>
+                <a:spcPts val="1800"/>
+              </a:spcBef>
               <a:spcAft>
                 <a:spcPts val="200"/>
               </a:spcAft>
-              <a:defRPr sz="2200" b="1">
+              <a:defRPr sz="2000" b="1">
                 <a:solidFill>
                   <a:srgbClr val="F8FAFC"/>
                 </a:solidFill>
@@ -3967,38 +4557,15 @@
               </a:defRPr>
             </a:pPr>
             <a:r>
-              <a:t>Compliance Score 100 → 0 (8 violation types)</a:t>
-            </a:r>
-          </a:p>
-        </p:txBody>
-      </p:sp>
-      <p:sp>
-        <p:nvSpPr>
-          <p:cNvPr id="7" name="TextBox 6"/>
-          <p:cNvSpPr txBox="1"/>
-          <p:nvPr/>
-        </p:nvSpPr>
-        <p:spPr>
-          <a:xfrm>
-            <a:off x="1371600" y="3858768"/>
-            <a:ext cx="6858000" cy="731520"/>
-          </a:xfrm>
-          <a:prstGeom prst="rect">
-            <a:avLst/>
-          </a:prstGeom>
-          <a:noFill/>
-        </p:spPr>
-        <p:txBody>
-          <a:bodyPr wrap="square">
-            <a:spAutoFit/>
-          </a:bodyPr>
-          <a:lstStyle/>
+              <a:t>Compliance Score 100 → 0 (8 violations)</a:t>
+            </a:r>
+          </a:p>
           <a:p>
             <a:pPr>
               <a:spcAft>
                 <a:spcPts val="0"/>
               </a:spcAft>
-              <a:defRPr sz="1600">
+              <a:defRPr sz="1400">
                 <a:solidFill>
                   <a:srgbClr val="94A3B8"/>
                 </a:solidFill>
@@ -4006,38 +4573,18 @@
               </a:defRPr>
             </a:pPr>
             <a:r>
-              <a:t>CRITICAL −25 (multiple deep work, overload &gt;7) · WARNING −10 (bucket overflow) · INFO −5 (no deep work, stale backlog)</a:t>
-            </a:r>
-          </a:p>
-        </p:txBody>
-      </p:sp>
-      <p:sp>
-        <p:nvSpPr>
-          <p:cNvPr id="8" name="TextBox 7"/>
-          <p:cNvSpPr txBox="1"/>
-          <p:nvPr/>
-        </p:nvSpPr>
-        <p:spPr>
-          <a:xfrm>
-            <a:off x="1371600" y="4846320"/>
-            <a:ext cx="6858000" cy="411480"/>
-          </a:xfrm>
-          <a:prstGeom prst="rect">
-            <a:avLst/>
-          </a:prstGeom>
-          <a:noFill/>
-        </p:spPr>
-        <p:txBody>
-          <a:bodyPr wrap="square">
-            <a:spAutoFit/>
-          </a:bodyPr>
-          <a:lstStyle/>
+              <a:t>CRITICAL −25 · WARNING −10 · INFO −5</a:t>
+            </a:r>
+          </a:p>
           <a:p>
             <a:pPr>
+              <a:spcBef>
+                <a:spcPts val="1800"/>
+              </a:spcBef>
               <a:spcAft>
                 <a:spcPts val="200"/>
               </a:spcAft>
-              <a:defRPr sz="2200" b="1">
+              <a:defRPr sz="2000" b="1">
                 <a:solidFill>
                   <a:srgbClr val="F8FAFC"/>
                 </a:solidFill>
@@ -4045,38 +4592,15 @@
               </a:defRPr>
             </a:pPr>
             <a:r>
-              <a:t>Timezone-Aware After-Hours Detection</a:t>
-            </a:r>
-          </a:p>
-        </p:txBody>
-      </p:sp>
-      <p:sp>
-        <p:nvSpPr>
-          <p:cNvPr id="9" name="TextBox 8"/>
-          <p:cNvSpPr txBox="1"/>
-          <p:nvPr/>
-        </p:nvSpPr>
-        <p:spPr>
-          <a:xfrm>
-            <a:off x="1371600" y="5230368"/>
-            <a:ext cx="6858000" cy="731520"/>
-          </a:xfrm>
-          <a:prstGeom prst="rect">
-            <a:avLst/>
-          </a:prstGeom>
-          <a:noFill/>
-        </p:spPr>
-        <p:txBody>
-          <a:bodyPr wrap="square">
-            <a:spAutoFit/>
-          </a:bodyPr>
-          <a:lstStyle/>
+              <a:t>3-3-3 Day Structure (classification runs twice)</a:t>
+            </a:r>
+          </a:p>
           <a:p>
             <a:pPr>
               <a:spcAft>
                 <a:spcPts val="0"/>
               </a:spcAft>
-              <a:defRPr sz="1600">
+              <a:defRPr sz="1400">
                 <a:solidFill>
                   <a:srgbClr val="94A3B8"/>
                 </a:solidFill>
@@ -4084,7 +4608,7 @@
               </a:defRPr>
             </a:pPr>
             <a:r>
-              <a:t>Working hours: 9 AM – 6 PM in the user's timezone — weekends always count as after-hours</a:t>
+              <a:t>1 deep work + 3 quick wins + 3 maintenance = 7 active max</a:t>
             </a:r>
           </a:p>
         </p:txBody>
@@ -4123,8 +4647,8 @@
         </p:nvSpPr>
         <p:spPr>
           <a:xfrm>
-            <a:off x="731520" y="640080"/>
-            <a:ext cx="7680960" cy="365760"/>
+            <a:off x="1097280" y="502920"/>
+            <a:ext cx="9997135" cy="320040"/>
           </a:xfrm>
           <a:prstGeom prst="rect">
             <a:avLst/>
@@ -4141,7 +4665,7 @@
               <a:spcAft>
                 <a:spcPts val="0"/>
               </a:spcAft>
-              <a:defRPr sz="1600" b="1">
+              <a:defRPr sz="1400" b="1">
                 <a:solidFill>
                   <a:srgbClr val="2DD4BF"/>
                 </a:solidFill>
@@ -4162,8 +4686,8 @@
         </p:nvSpPr>
         <p:spPr>
           <a:xfrm>
-            <a:off x="731520" y="1005840"/>
-            <a:ext cx="7680960" cy="731520"/>
+            <a:off x="1097280" y="822960"/>
+            <a:ext cx="9997135" cy="594360"/>
           </a:xfrm>
           <a:prstGeom prst="rect">
             <a:avLst/>
@@ -4180,7 +4704,7 @@
               <a:spcAft>
                 <a:spcPts val="0"/>
               </a:spcAft>
-              <a:defRPr sz="4000" b="1">
+              <a:defRPr sz="3600" b="1">
                 <a:solidFill>
                   <a:srgbClr val="F8FAFC"/>
                 </a:solidFill>
@@ -4201,8 +4725,8 @@
         </p:nvSpPr>
         <p:spPr>
           <a:xfrm>
-            <a:off x="1371600" y="2103120"/>
-            <a:ext cx="6858000" cy="411480"/>
+            <a:off x="1463040" y="1828800"/>
+            <a:ext cx="9265615" cy="2926080"/>
           </a:xfrm>
           <a:prstGeom prst="rect">
             <a:avLst/>
@@ -4216,10 +4740,13 @@
           <a:lstStyle/>
           <a:p>
             <a:pPr>
+              <a:spcBef>
+                <a:spcPts val="0"/>
+              </a:spcBef>
               <a:spcAft>
                 <a:spcPts val="200"/>
               </a:spcAft>
-              <a:defRPr sz="2200" b="1">
+              <a:defRPr sz="2000" b="1">
                 <a:solidFill>
                   <a:srgbClr val="F8FAFC"/>
                 </a:solidFill>
@@ -4230,35 +4757,12 @@
               <a:t>6-Component Breakdown</a:t>
             </a:r>
           </a:p>
-        </p:txBody>
-      </p:sp>
-      <p:sp>
-        <p:nvSpPr>
-          <p:cNvPr id="5" name="TextBox 4"/>
-          <p:cNvSpPr txBox="1"/>
-          <p:nvPr/>
-        </p:nvSpPr>
-        <p:spPr>
-          <a:xfrm>
-            <a:off x="1371600" y="2487168"/>
-            <a:ext cx="6858000" cy="731520"/>
-          </a:xfrm>
-          <a:prstGeom prst="rect">
-            <a:avLst/>
-          </a:prstGeom>
-          <a:noFill/>
-        </p:spPr>
-        <p:txBody>
-          <a:bodyPr wrap="square">
-            <a:spAutoFit/>
-          </a:bodyPr>
-          <a:lstStyle/>
           <a:p>
             <a:pPr>
               <a:spcAft>
                 <a:spcPts val="0"/>
               </a:spcAft>
-              <a:defRPr sz="1600">
+              <a:defRPr sz="1400">
                 <a:solidFill>
                   <a:srgbClr val="94A3B8"/>
                 </a:solidFill>
@@ -4266,38 +4770,18 @@
               </a:defRPr>
             </a:pPr>
             <a:r>
-              <a:t>Workload (0–40) · Chaos (0–30) · Context Switching (0–15) · Clarity (0–10) · Sustained Load (0–15) · After Hours (0–10)</a:t>
-            </a:r>
-          </a:p>
-        </p:txBody>
-      </p:sp>
-      <p:sp>
-        <p:nvSpPr>
-          <p:cNvPr id="6" name="TextBox 5"/>
-          <p:cNvSpPr txBox="1"/>
-          <p:nvPr/>
-        </p:nvSpPr>
-        <p:spPr>
-          <a:xfrm>
-            <a:off x="1371600" y="3474720"/>
-            <a:ext cx="6858000" cy="411480"/>
-          </a:xfrm>
-          <a:prstGeom prst="rect">
-            <a:avLst/>
-          </a:prstGeom>
-          <a:noFill/>
-        </p:spPr>
-        <p:txBody>
-          <a:bodyPr wrap="square">
-            <a:spAutoFit/>
-          </a:bodyPr>
-          <a:lstStyle/>
+              <a:t>Workload · Chaos · Context Switching · Clarity · Sustained · After Hours</a:t>
+            </a:r>
+          </a:p>
           <a:p>
             <a:pPr>
+              <a:spcBef>
+                <a:spcPts val="1800"/>
+              </a:spcBef>
               <a:spcAft>
                 <a:spcPts val="200"/>
               </a:spcAft>
-              <a:defRPr sz="2200" b="1">
+              <a:defRPr sz="2000" b="1">
                 <a:solidFill>
                   <a:srgbClr val="F8FAFC"/>
                 </a:solidFill>
@@ -4308,35 +4792,12 @@
               <a:t>4 Stress Levels</a:t>
             </a:r>
           </a:p>
-        </p:txBody>
-      </p:sp>
-      <p:sp>
-        <p:nvSpPr>
-          <p:cNvPr id="7" name="TextBox 6"/>
-          <p:cNvSpPr txBox="1"/>
-          <p:nvPr/>
-        </p:nvSpPr>
-        <p:spPr>
-          <a:xfrm>
-            <a:off x="1371600" y="3858768"/>
-            <a:ext cx="6858000" cy="731520"/>
-          </a:xfrm>
-          <a:prstGeom prst="rect">
-            <a:avLst/>
-          </a:prstGeom>
-          <a:noFill/>
-        </p:spPr>
-        <p:txBody>
-          <a:bodyPr wrap="square">
-            <a:spAutoFit/>
-          </a:bodyPr>
-          <a:lstStyle/>
           <a:p>
             <a:pPr>
               <a:spcAft>
                 <a:spcPts val="0"/>
               </a:spcAft>
-              <a:defRPr sz="1600">
+              <a:defRPr sz="1400">
                 <a:solidFill>
                   <a:srgbClr val="94A3B8"/>
                 </a:solidFill>
@@ -4347,35 +4808,15 @@
               <a:t>≥ 70 CRITICAL · ≥ 50 HIGH · ≥ 30 MODERATE · &lt; 30 LOW</a:t>
             </a:r>
           </a:p>
-        </p:txBody>
-      </p:sp>
-      <p:sp>
-        <p:nvSpPr>
-          <p:cNvPr id="8" name="TextBox 7"/>
-          <p:cNvSpPr txBox="1"/>
-          <p:nvPr/>
-        </p:nvSpPr>
-        <p:spPr>
-          <a:xfrm>
-            <a:off x="1371600" y="4846320"/>
-            <a:ext cx="6858000" cy="411480"/>
-          </a:xfrm>
-          <a:prstGeom prst="rect">
-            <a:avLst/>
-          </a:prstGeom>
-          <a:noFill/>
-        </p:spPr>
-        <p:txBody>
-          <a:bodyPr wrap="square">
-            <a:spAutoFit/>
-          </a:bodyPr>
-          <a:lstStyle/>
           <a:p>
             <a:pPr>
+              <a:spcBef>
+                <a:spcPts val="1800"/>
+              </a:spcBef>
               <a:spcAft>
                 <a:spcPts val="200"/>
               </a:spcAft>
-              <a:defRPr sz="2200" b="1">
+              <a:defRPr sz="2000" b="1">
                 <a:solidFill>
                   <a:srgbClr val="F8FAFC"/>
                 </a:solidFill>
@@ -4386,35 +4827,12 @@
               <a:t>12 Capped World State Variables</a:t>
             </a:r>
           </a:p>
-        </p:txBody>
-      </p:sp>
-      <p:sp>
-        <p:nvSpPr>
-          <p:cNvPr id="9" name="TextBox 8"/>
-          <p:cNvSpPr txBox="1"/>
-          <p:nvPr/>
-        </p:nvSpPr>
-        <p:spPr>
-          <a:xfrm>
-            <a:off x="1371600" y="5230368"/>
-            <a:ext cx="6858000" cy="731520"/>
-          </a:xfrm>
-          <a:prstGeom prst="rect">
-            <a:avLst/>
-          </a:prstGeom>
-          <a:noFill/>
-        </p:spPr>
-        <p:txBody>
-          <a:bodyPr wrap="square">
-            <a:spAutoFit/>
-          </a:bodyPr>
-          <a:lstStyle/>
           <a:p>
             <a:pPr>
               <a:spcAft>
                 <a:spcPts val="0"/>
               </a:spcAft>
-              <a:defRPr sz="1600">
+              <a:defRPr sz="1400">
                 <a:solidFill>
                   <a:srgbClr val="94A3B8"/>
                 </a:solidFill>
@@ -4422,7 +4840,7 @@
               </a:defRPr>
             </a:pPr>
             <a:r>
-              <a:t>All inputs are capped (e.g. totalAssigned ≤ 15, deferred ≤ 10, mysteryMeat ≤ 10) to prevent overflow and keep scores deterministic</a:t>
+              <a:t>All inputs capped to prevent overflow and keep scores deterministic</a:t>
             </a:r>
           </a:p>
         </p:txBody>
@@ -4461,8 +4879,8 @@
         </p:nvSpPr>
         <p:spPr>
           <a:xfrm>
-            <a:off x="731520" y="640080"/>
-            <a:ext cx="7680960" cy="365760"/>
+            <a:off x="1097280" y="502920"/>
+            <a:ext cx="9997135" cy="320040"/>
           </a:xfrm>
           <a:prstGeom prst="rect">
             <a:avLst/>
@@ -4479,7 +4897,7 @@
               <a:spcAft>
                 <a:spcPts val="0"/>
               </a:spcAft>
-              <a:defRPr sz="1600" b="1">
+              <a:defRPr sz="1400" b="1">
                 <a:solidFill>
                   <a:srgbClr val="FB7185"/>
                 </a:solidFill>
@@ -4500,8 +4918,8 @@
         </p:nvSpPr>
         <p:spPr>
           <a:xfrm>
-            <a:off x="731520" y="1005840"/>
-            <a:ext cx="7680960" cy="731520"/>
+            <a:off x="1097280" y="822960"/>
+            <a:ext cx="9997135" cy="594360"/>
           </a:xfrm>
           <a:prstGeom prst="rect">
             <a:avLst/>
@@ -4518,7 +4936,7 @@
               <a:spcAft>
                 <a:spcPts val="0"/>
               </a:spcAft>
-              <a:defRPr sz="4000" b="1">
+              <a:defRPr sz="3600" b="1">
                 <a:solidFill>
                   <a:srgbClr val="F8FAFC"/>
                 </a:solidFill>
@@ -4539,8 +4957,8 @@
         </p:nvSpPr>
         <p:spPr>
           <a:xfrm>
-            <a:off x="1371600" y="2103120"/>
-            <a:ext cx="6858000" cy="411480"/>
+            <a:off x="1463040" y="1828800"/>
+            <a:ext cx="9265615" cy="2926080"/>
           </a:xfrm>
           <a:prstGeom prst="rect">
             <a:avLst/>
@@ -4554,10 +4972,13 @@
           <a:lstStyle/>
           <a:p>
             <a:pPr>
+              <a:spcBef>
+                <a:spcPts val="0"/>
+              </a:spcBef>
               <a:spcAft>
                 <a:spcPts val="200"/>
               </a:spcAft>
-              <a:defRPr sz="2200" b="1">
+              <a:defRPr sz="2000" b="1">
                 <a:solidFill>
                   <a:srgbClr val="F8FAFC"/>
                 </a:solidFill>
@@ -4565,38 +4986,15 @@
               </a:defRPr>
             </a:pPr>
             <a:r>
-              <a:t>LangChain4j Supervisor with 5 Sub-Agents</a:t>
-            </a:r>
-          </a:p>
-        </p:txBody>
-      </p:sp>
-      <p:sp>
-        <p:nvSpPr>
-          <p:cNvPr id="5" name="TextBox 4"/>
-          <p:cNvSpPr txBox="1"/>
-          <p:nvPr/>
-        </p:nvSpPr>
-        <p:spPr>
-          <a:xfrm>
-            <a:off x="1371600" y="2487168"/>
-            <a:ext cx="6858000" cy="731520"/>
-          </a:xfrm>
-          <a:prstGeom prst="rect">
-            <a:avLst/>
-          </a:prstGeom>
-          <a:noFill/>
-        </p:spPr>
-        <p:txBody>
-          <a:bodyPr wrap="square">
-            <a:spAutoFit/>
-          </a:bodyPr>
-          <a:lstStyle/>
+              <a:t>LangChain4j Supervisor — 5 Sub-Agents</a:t>
+            </a:r>
+          </a:p>
           <a:p>
             <a:pPr>
               <a:spcAft>
                 <a:spcPts val="0"/>
               </a:spcAft>
-              <a:defRPr sz="1600">
+              <a:defRPr sz="1400">
                 <a:solidFill>
                   <a:srgbClr val="94A3B8"/>
                 </a:solidFill>
@@ -4604,38 +5002,18 @@
               </a:defRPr>
             </a:pPr>
             <a:r>
-              <a:t>DeferAgent · DelegateAgent · ClassifyAgent · ScopeAgent · WellnessAgent — each with @Tool methods that apply GitHub labels</a:t>
-            </a:r>
-          </a:p>
-        </p:txBody>
-      </p:sp>
-      <p:sp>
-        <p:nvSpPr>
-          <p:cNvPr id="6" name="TextBox 5"/>
-          <p:cNvSpPr txBox="1"/>
-          <p:nvPr/>
-        </p:nvSpPr>
-        <p:spPr>
-          <a:xfrm>
-            <a:off x="1371600" y="3474720"/>
-            <a:ext cx="6858000" cy="411480"/>
-          </a:xfrm>
-          <a:prstGeom prst="rect">
-            <a:avLst/>
-          </a:prstGeom>
-          <a:noFill/>
-        </p:spPr>
-        <p:txBody>
-          <a:bodyPr wrap="square">
-            <a:spAutoFit/>
-          </a:bodyPr>
-          <a:lstStyle/>
+              <a:t>Defer · Delegate · Classify · Scope · Wellness</a:t>
+            </a:r>
+          </a:p>
           <a:p>
             <a:pPr>
+              <a:spcBef>
+                <a:spcPts val="1800"/>
+              </a:spcBef>
               <a:spcAft>
                 <a:spcPts val="200"/>
               </a:spcAft>
-              <a:defRPr sz="2200" b="1">
+              <a:defRPr sz="2000" b="1">
                 <a:solidFill>
                   <a:srgbClr val="F8FAFC"/>
                 </a:solidFill>
@@ -4646,35 +5024,12 @@
               <a:t>Protection Triggers Automatically</a:t>
             </a:r>
           </a:p>
-        </p:txBody>
-      </p:sp>
-      <p:sp>
-        <p:nvSpPr>
-          <p:cNvPr id="7" name="TextBox 6"/>
-          <p:cNvSpPr txBox="1"/>
-          <p:nvPr/>
-        </p:nvSpPr>
-        <p:spPr>
-          <a:xfrm>
-            <a:off x="1371600" y="3858768"/>
-            <a:ext cx="6858000" cy="731520"/>
-          </a:xfrm>
-          <a:prstGeom prst="rect">
-            <a:avLst/>
-          </a:prstGeom>
-          <a:noFill/>
-        </p:spPr>
-        <p:txBody>
-          <a:bodyPr wrap="square">
-            <a:spAutoFit/>
-          </a:bodyPr>
-          <a:lstStyle/>
           <a:p>
             <a:pPr>
               <a:spcAft>
                 <a:spcPts val="0"/>
               </a:spcAft>
-              <a:defRPr sz="1600">
+              <a:defRPr sz="1400">
                 <a:solidFill>
                   <a:srgbClr val="94A3B8"/>
                 </a:solidFill>
@@ -4682,38 +5037,18 @@
               </a:defRPr>
             </a:pPr>
             <a:r>
-              <a:t>Fires when: 2+ consecutive high-chaos days, after-hours activity, stress ≥ 70, or 10+ assigned issues</a:t>
-            </a:r>
-          </a:p>
-        </p:txBody>
-      </p:sp>
-      <p:sp>
-        <p:nvSpPr>
-          <p:cNvPr id="8" name="TextBox 7"/>
-          <p:cNvSpPr txBox="1"/>
-          <p:nvPr/>
-        </p:nvSpPr>
-        <p:spPr>
-          <a:xfrm>
-            <a:off x="1371600" y="4846320"/>
-            <a:ext cx="6858000" cy="411480"/>
-          </a:xfrm>
-          <a:prstGeom prst="rect">
-            <a:avLst/>
-          </a:prstGeom>
-          <a:noFill/>
-        </p:spPr>
-        <p:txBody>
-          <a:bodyPr wrap="square">
-            <a:spAutoFit/>
-          </a:bodyPr>
-          <a:lstStyle/>
+              <a:t>2+ high-chaos days, after-hours, stress ≥ 70, or 10+ issues</a:t>
+            </a:r>
+          </a:p>
           <a:p>
             <a:pPr>
+              <a:spcBef>
+                <a:spcPts val="1800"/>
+              </a:spcBef>
               <a:spcAft>
                 <a:spcPts val="200"/>
               </a:spcAft>
-              <a:defRPr sz="2200" b="1">
+              <a:defRPr sz="2000" b="1">
                 <a:solidFill>
                   <a:srgbClr val="F8FAFC"/>
                 </a:solidFill>
@@ -4724,35 +5059,12 @@
               <a:t>Deterministic Fallback — Always Works</a:t>
             </a:r>
           </a:p>
-        </p:txBody>
-      </p:sp>
-      <p:sp>
-        <p:nvSpPr>
-          <p:cNvPr id="9" name="TextBox 8"/>
-          <p:cNvSpPr txBox="1"/>
-          <p:nvPr/>
-        </p:nvSpPr>
-        <p:spPr>
-          <a:xfrm>
-            <a:off x="1371600" y="5230368"/>
-            <a:ext cx="6858000" cy="731520"/>
-          </a:xfrm>
-          <a:prstGeom prst="rect">
-            <a:avLst/>
-          </a:prstGeom>
-          <a:noFill/>
-        </p:spPr>
-        <p:txBody>
-          <a:bodyPr wrap="square">
-            <a:spAutoFit/>
-          </a:bodyPr>
-          <a:lstStyle/>
           <a:p>
             <a:pPr>
               <a:spcAft>
                 <a:spcPts val="0"/>
               </a:spcAft>
-              <a:defRPr sz="1600">
+              <a:defRPr sz="1400">
                 <a:solidFill>
                   <a:srgbClr val="94A3B8"/>
                 </a:solidFill>
@@ -4760,7 +5072,7 @@
               </a:defRPr>
             </a:pPr>
             <a:r>
-              <a:t>Every AI agent has a fallback path — when the LLM is unavailable, all features continue with deterministic responses</a:t>
+              <a:t>Every agent has a fallback when the LLM is unavailable</a:t>
             </a:r>
           </a:p>
         </p:txBody>
@@ -4799,8 +5111,8 @@
         </p:nvSpPr>
         <p:spPr>
           <a:xfrm>
-            <a:off x="731520" y="640080"/>
-            <a:ext cx="7680960" cy="365760"/>
+            <a:off x="1097280" y="502920"/>
+            <a:ext cx="9997135" cy="320040"/>
           </a:xfrm>
           <a:prstGeom prst="rect">
             <a:avLst/>
@@ -4817,7 +5129,7 @@
               <a:spcAft>
                 <a:spcPts val="0"/>
               </a:spcAft>
-              <a:defRPr sz="1600" b="1">
+              <a:defRPr sz="1400" b="1">
                 <a:solidFill>
                   <a:srgbClr val="818CF8"/>
                 </a:solidFill>
@@ -4838,8 +5150,8 @@
         </p:nvSpPr>
         <p:spPr>
           <a:xfrm>
-            <a:off x="731520" y="1005840"/>
-            <a:ext cx="7680960" cy="731520"/>
+            <a:off x="1097280" y="822960"/>
+            <a:ext cx="9997135" cy="594360"/>
           </a:xfrm>
           <a:prstGeom prst="rect">
             <a:avLst/>
@@ -4856,7 +5168,7 @@
               <a:spcAft>
                 <a:spcPts val="0"/>
               </a:spcAft>
-              <a:defRPr sz="4000" b="1">
+              <a:defRPr sz="3600" b="1">
                 <a:solidFill>
                   <a:srgbClr val="F8FAFC"/>
                 </a:solidFill>
@@ -4877,8 +5189,8 @@
         </p:nvSpPr>
         <p:spPr>
           <a:xfrm>
-            <a:off x="1371600" y="2103120"/>
-            <a:ext cx="6858000" cy="411480"/>
+            <a:off x="1463040" y="1828800"/>
+            <a:ext cx="9265615" cy="2926080"/>
           </a:xfrm>
           <a:prstGeom prst="rect">
             <a:avLst/>
@@ -4892,10 +5204,13 @@
           <a:lstStyle/>
           <a:p>
             <a:pPr>
+              <a:spcBef>
+                <a:spcPts val="0"/>
+              </a:spcBef>
               <a:spcAft>
                 <a:spcPts val="200"/>
               </a:spcAft>
-              <a:defRPr sz="2200" b="1">
+              <a:defRPr sz="2000" b="1">
                 <a:solidFill>
                   <a:srgbClr val="F8FAFC"/>
                 </a:solidFill>
@@ -4906,35 +5221,12 @@
               <a:t>GitHub Mutation Plan</a:t>
             </a:r>
           </a:p>
-        </p:txBody>
-      </p:sp>
-      <p:sp>
-        <p:nvSpPr>
-          <p:cNvPr id="5" name="TextBox 4"/>
-          <p:cNvSpPr txBox="1"/>
-          <p:nvPr/>
-        </p:nvSpPr>
-        <p:spPr>
-          <a:xfrm>
-            <a:off x="1371600" y="2487168"/>
-            <a:ext cx="6858000" cy="731520"/>
-          </a:xfrm>
-          <a:prstGeom prst="rect">
-            <a:avLst/>
-          </a:prstGeom>
-          <a:noFill/>
-        </p:spPr>
-        <p:txBody>
-          <a:bodyPr wrap="square">
-            <a:spAutoFit/>
-          </a:bodyPr>
-          <a:lstStyle/>
           <a:p>
             <a:pPr>
               <a:spcAft>
                 <a:spcPts val="0"/>
               </a:spcAft>
-              <a:defRPr sz="1600">
+              <a:defRPr sz="1400">
                 <a:solidFill>
                   <a:srgbClr val="94A3B8"/>
                 </a:solidFill>
@@ -4942,38 +5234,18 @@
               </a:defRPr>
             </a:pPr>
             <a:r>
-              <a:t>Applies labels (deferred, quick-win, deep-work, 3-3-3, needs-scope…) and comments to reshape your day into the 3-3-3 structure</a:t>
-            </a:r>
-          </a:p>
-        </p:txBody>
-      </p:sp>
-      <p:sp>
-        <p:nvSpPr>
-          <p:cNvPr id="6" name="TextBox 5"/>
-          <p:cNvSpPr txBox="1"/>
-          <p:nvPr/>
-        </p:nvSpPr>
-        <p:spPr>
-          <a:xfrm>
-            <a:off x="1371600" y="3474720"/>
-            <a:ext cx="6858000" cy="411480"/>
-          </a:xfrm>
-          <a:prstGeom prst="rect">
-            <a:avLst/>
-          </a:prstGeom>
-          <a:noFill/>
-        </p:spPr>
-        <p:txBody>
-          <a:bodyPr wrap="square">
-            <a:spAutoFit/>
-          </a:bodyPr>
-          <a:lstStyle/>
+              <a:t>Labels and comments applied to reshape your day into 3-3-3</a:t>
+            </a:r>
+          </a:p>
           <a:p>
             <a:pPr>
+              <a:spcBef>
+                <a:spcPts val="1800"/>
+              </a:spcBef>
               <a:spcAft>
                 <a:spcPts val="200"/>
               </a:spcAft>
-              <a:defRPr sz="2200" b="1">
+              <a:defRPr sz="2000" b="1">
                 <a:solidFill>
                   <a:srgbClr val="F8FAFC"/>
                 </a:solidFill>
@@ -4984,35 +5256,12 @@
               <a:t>Friday Deploy Score (0–100)</a:t>
             </a:r>
           </a:p>
-        </p:txBody>
-      </p:sp>
-      <p:sp>
-        <p:nvSpPr>
-          <p:cNvPr id="7" name="TextBox 6"/>
-          <p:cNvSpPr txBox="1"/>
-          <p:nvPr/>
-        </p:nvSpPr>
-        <p:spPr>
-          <a:xfrm>
-            <a:off x="1371600" y="3858768"/>
-            <a:ext cx="6858000" cy="731520"/>
-          </a:xfrm>
-          <a:prstGeom prst="rect">
-            <a:avLst/>
-          </a:prstGeom>
-          <a:noFill/>
-        </p:spPr>
-        <p:txBody>
-          <a:bodyPr wrap="square">
-            <a:spAutoFit/>
-          </a:bodyPr>
-          <a:lstStyle/>
           <a:p>
             <a:pPr>
               <a:spcAft>
                 <a:spcPts val="0"/>
               </a:spcAft>
-              <a:defRPr sz="1600">
+              <a:defRPr sz="1400">
                 <a:solidFill>
                   <a:srgbClr val="94A3B8"/>
                 </a:solidFill>
@@ -5020,38 +5269,18 @@
               </a:defRPr>
             </a:pPr>
             <a:r>
-              <a:t>Deductions for chaos &gt;5, urgent unassigned, after-hours, mystery meat — status: READY ≥ 80 · CAUTION ≥ 50 · NOT_READY &lt; 50</a:t>
-            </a:r>
-          </a:p>
-        </p:txBody>
-      </p:sp>
-      <p:sp>
-        <p:nvSpPr>
-          <p:cNvPr id="8" name="TextBox 7"/>
-          <p:cNvSpPr txBox="1"/>
-          <p:nvPr/>
-        </p:nvSpPr>
-        <p:spPr>
-          <a:xfrm>
-            <a:off x="1371600" y="4846320"/>
-            <a:ext cx="6858000" cy="411480"/>
-          </a:xfrm>
-          <a:prstGeom prst="rect">
-            <a:avLst/>
-          </a:prstGeom>
-          <a:noFill/>
-        </p:spPr>
-        <p:txBody>
-          <a:bodyPr wrap="square">
-            <a:spAutoFit/>
-          </a:bodyPr>
-          <a:lstStyle/>
+              <a:t>READY ≥ 80 · CAUTION ≥ 50 · NOT_READY &lt; 50</a:t>
+            </a:r>
+          </a:p>
           <a:p>
             <a:pPr>
+              <a:spcBef>
+                <a:spcPts val="1800"/>
+              </a:spcBef>
               <a:spcAft>
                 <a:spcPts val="200"/>
               </a:spcAft>
-              <a:defRPr sz="2200" b="1">
+              <a:defRPr sz="2000" b="1">
                 <a:solidFill>
                   <a:srgbClr val="F8FAFC"/>
                 </a:solidFill>
@@ -5062,35 +5291,12 @@
               <a:t>Stress Snapshots Persisted (JPA)</a:t>
             </a:r>
           </a:p>
-        </p:txBody>
-      </p:sp>
-      <p:sp>
-        <p:nvSpPr>
-          <p:cNvPr id="9" name="TextBox 8"/>
-          <p:cNvSpPr txBox="1"/>
-          <p:nvPr/>
-        </p:nvSpPr>
-        <p:spPr>
-          <a:xfrm>
-            <a:off x="1371600" y="5230368"/>
-            <a:ext cx="6858000" cy="731520"/>
-          </a:xfrm>
-          <a:prstGeom prst="rect">
-            <a:avLst/>
-          </a:prstGeom>
-          <a:noFill/>
-        </p:spPr>
-        <p:txBody>
-          <a:bodyPr wrap="square">
-            <a:spAutoFit/>
-          </a:bodyPr>
-          <a:lstStyle/>
           <a:p>
             <a:pPr>
               <a:spcAft>
                 <a:spcPts val="0"/>
               </a:spcAft>
-              <a:defRPr sz="1600">
+              <a:defRPr sz="1400">
                 <a:solidFill>
                   <a:srgbClr val="94A3B8"/>
                 </a:solidFill>
@@ -5098,7 +5304,7 @@
               </a:defRPr>
             </a:pPr>
             <a:r>
-              <a:t>Every check-in saved with all 6 breakdown components + optional self-report — powers the Study Dashboard trend charts</a:t>
+              <a:t>All 6 breakdown components + self-report saved for trend analysis</a:t>
             </a:r>
           </a:p>
         </p:txBody>
@@ -5429,4 +5635,324 @@
   </a:objectDefaults>
   <a:extraClrSchemeLst/>
 </a:theme>
+</file>
+
+<file path=ppt/theme/theme2.xml><?xml version="1.0" encoding="utf-8"?>
+<a:theme xmlns:a="http://schemas.openxmlformats.org/drawingml/2006/main" name="Office Theme">
+  <a:themeElements>
+    <a:clrScheme name="Office">
+      <a:dk1>
+        <a:sysClr val="windowText" lastClr="000000"/>
+      </a:dk1>
+      <a:lt1>
+        <a:sysClr val="window" lastClr="FFFFFF"/>
+      </a:lt1>
+      <a:dk2>
+        <a:srgbClr val="1F497D"/>
+      </a:dk2>
+      <a:lt2>
+        <a:srgbClr val="EEECE1"/>
+      </a:lt2>
+      <a:accent1>
+        <a:srgbClr val="4F81BD"/>
+      </a:accent1>
+      <a:accent2>
+        <a:srgbClr val="C0504D"/>
+      </a:accent2>
+      <a:accent3>
+        <a:srgbClr val="9BBB59"/>
+      </a:accent3>
+      <a:accent4>
+        <a:srgbClr val="8064A2"/>
+      </a:accent4>
+      <a:accent5>
+        <a:srgbClr val="4BACC6"/>
+      </a:accent5>
+      <a:accent6>
+        <a:srgbClr val="F79646"/>
+      </a:accent6>
+      <a:hlink>
+        <a:srgbClr val="0000FF"/>
+      </a:hlink>
+      <a:folHlink>
+        <a:srgbClr val="800080"/>
+      </a:folHlink>
+    </a:clrScheme>
+    <a:fontScheme name="Office">
+      <a:majorFont>
+        <a:latin typeface="Calibri"/>
+        <a:ea typeface=""/>
+        <a:cs typeface=""/>
+        <a:font script="Jpan" typeface="ＭＳ Ｐゴシック"/>
+        <a:font script="Hang" typeface="맑은 고딕"/>
+        <a:font script="Hans" typeface="宋体"/>
+        <a:font script="Hant" typeface="新細明體"/>
+        <a:font script="Arab" typeface="Times New Roman"/>
+        <a:font script="Hebr" typeface="Times New Roman"/>
+        <a:font script="Thai" typeface="Angsana New"/>
+        <a:font script="Ethi" typeface="Nyala"/>
+        <a:font script="Beng" typeface="Vrinda"/>
+        <a:font script="Gujr" typeface="Shruti"/>
+        <a:font script="Khmr" typeface="MoolBoran"/>
+        <a:font script="Knda" typeface="Tunga"/>
+        <a:font script="Guru" typeface="Raavi"/>
+        <a:font script="Cans" typeface="Euphemia"/>
+        <a:font script="Cher" typeface="Plantagenet Cherokee"/>
+        <a:font script="Yiii" typeface="Microsoft Yi Baiti"/>
+        <a:font script="Tibt" typeface="Microsoft Himalaya"/>
+        <a:font script="Thaa" typeface="MV Boli"/>
+        <a:font script="Deva" typeface="Mangal"/>
+        <a:font script="Telu" typeface="Gautami"/>
+        <a:font script="Taml" typeface="Latha"/>
+        <a:font script="Syrc" typeface="Estrangelo Edessa"/>
+        <a:font script="Orya" typeface="Kalinga"/>
+        <a:font script="Mlym" typeface="Kartika"/>
+        <a:font script="Laoo" typeface="DokChampa"/>
+        <a:font script="Sinh" typeface="Iskoola Pota"/>
+        <a:font script="Mong" typeface="Mongolian Baiti"/>
+        <a:font script="Viet" typeface="Times New Roman"/>
+        <a:font script="Uigh" typeface="Microsoft Uighur"/>
+        <a:font script="Geor" typeface="Sylfaen"/>
+      </a:majorFont>
+      <a:minorFont>
+        <a:latin typeface="Calibri"/>
+        <a:ea typeface=""/>
+        <a:cs typeface=""/>
+        <a:font script="Jpan" typeface="ＭＳ Ｐゴシック"/>
+        <a:font script="Hang" typeface="맑은 고딕"/>
+        <a:font script="Hans" typeface="宋体"/>
+        <a:font script="Hant" typeface="新細明體"/>
+        <a:font script="Arab" typeface="Arial"/>
+        <a:font script="Hebr" typeface="Arial"/>
+        <a:font script="Thai" typeface="Cordia New"/>
+        <a:font script="Ethi" typeface="Nyala"/>
+        <a:font script="Beng" typeface="Vrinda"/>
+        <a:font script="Gujr" typeface="Shruti"/>
+        <a:font script="Khmr" typeface="DaunPenh"/>
+        <a:font script="Knda" typeface="Tunga"/>
+        <a:font script="Guru" typeface="Raavi"/>
+        <a:font script="Cans" typeface="Euphemia"/>
+        <a:font script="Cher" typeface="Plantagenet Cherokee"/>
+        <a:font script="Yiii" typeface="Microsoft Yi Baiti"/>
+        <a:font script="Tibt" typeface="Microsoft Himalaya"/>
+        <a:font script="Thaa" typeface="MV Boli"/>
+        <a:font script="Deva" typeface="Mangal"/>
+        <a:font script="Telu" typeface="Gautami"/>
+        <a:font script="Taml" typeface="Latha"/>
+        <a:font script="Syrc" typeface="Estrangelo Edessa"/>
+        <a:font script="Orya" typeface="Kalinga"/>
+        <a:font script="Mlym" typeface="Kartika"/>
+        <a:font script="Laoo" typeface="DokChampa"/>
+        <a:font script="Sinh" typeface="Iskoola Pota"/>
+        <a:font script="Mong" typeface="Mongolian Baiti"/>
+        <a:font script="Viet" typeface="Arial"/>
+        <a:font script="Uigh" typeface="Microsoft Uighur"/>
+        <a:font script="Geor" typeface="Sylfaen"/>
+      </a:minorFont>
+    </a:fontScheme>
+    <a:fmtScheme name="Office">
+      <a:fillStyleLst>
+        <a:solidFill>
+          <a:schemeClr val="phClr"/>
+        </a:solidFill>
+        <a:gradFill rotWithShape="1">
+          <a:gsLst>
+            <a:gs pos="0">
+              <a:schemeClr val="phClr">
+                <a:tint val="50000"/>
+                <a:satMod val="300000"/>
+              </a:schemeClr>
+            </a:gs>
+            <a:gs pos="35000">
+              <a:schemeClr val="phClr">
+                <a:tint val="37000"/>
+                <a:satMod val="300000"/>
+              </a:schemeClr>
+            </a:gs>
+            <a:gs pos="100000">
+              <a:schemeClr val="phClr">
+                <a:tint val="15000"/>
+                <a:satMod val="350000"/>
+              </a:schemeClr>
+            </a:gs>
+          </a:gsLst>
+          <a:lin ang="16200000" scaled="1"/>
+        </a:gradFill>
+        <a:gradFill rotWithShape="1">
+          <a:gsLst>
+            <a:gs pos="0">
+              <a:schemeClr val="phClr">
+                <a:tint val="100000"/>
+                <a:shade val="100000"/>
+                <a:satMod val="130000"/>
+              </a:schemeClr>
+            </a:gs>
+            <a:gs pos="100000">
+              <a:schemeClr val="phClr">
+                <a:tint val="50000"/>
+                <a:shade val="100000"/>
+                <a:satMod val="350000"/>
+              </a:schemeClr>
+            </a:gs>
+          </a:gsLst>
+          <a:lin ang="16200000" scaled="0"/>
+        </a:gradFill>
+      </a:fillStyleLst>
+      <a:lnStyleLst>
+        <a:ln w="9525" cap="flat" cmpd="sng" algn="ctr">
+          <a:solidFill>
+            <a:schemeClr val="phClr">
+              <a:shade val="95000"/>
+              <a:satMod val="105000"/>
+            </a:schemeClr>
+          </a:solidFill>
+          <a:prstDash val="solid"/>
+        </a:ln>
+        <a:ln w="25400" cap="flat" cmpd="sng" algn="ctr">
+          <a:solidFill>
+            <a:schemeClr val="phClr"/>
+          </a:solidFill>
+          <a:prstDash val="solid"/>
+        </a:ln>
+        <a:ln w="38100" cap="flat" cmpd="sng" algn="ctr">
+          <a:solidFill>
+            <a:schemeClr val="phClr"/>
+          </a:solidFill>
+          <a:prstDash val="solid"/>
+        </a:ln>
+      </a:lnStyleLst>
+      <a:effectStyleLst>
+        <a:effectStyle>
+          <a:effectLst>
+            <a:outerShdw blurRad="40000" dist="20000" dir="5400000" rotWithShape="0">
+              <a:srgbClr val="000000">
+                <a:alpha val="38000"/>
+              </a:srgbClr>
+            </a:outerShdw>
+          </a:effectLst>
+        </a:effectStyle>
+        <a:effectStyle>
+          <a:effectLst>
+            <a:outerShdw blurRad="40000" dist="23000" dir="5400000" rotWithShape="0">
+              <a:srgbClr val="000000">
+                <a:alpha val="35000"/>
+              </a:srgbClr>
+            </a:outerShdw>
+          </a:effectLst>
+        </a:effectStyle>
+        <a:effectStyle>
+          <a:effectLst>
+            <a:outerShdw blurRad="40000" dist="23000" dir="5400000" rotWithShape="0">
+              <a:srgbClr val="000000">
+                <a:alpha val="35000"/>
+              </a:srgbClr>
+            </a:outerShdw>
+          </a:effectLst>
+          <a:scene3d>
+            <a:camera prst="orthographicFront">
+              <a:rot lat="0" lon="0" rev="0"/>
+            </a:camera>
+            <a:lightRig rig="threePt" dir="t">
+              <a:rot lat="0" lon="0" rev="1200000"/>
+            </a:lightRig>
+          </a:scene3d>
+          <a:sp3d>
+            <a:bevelT w="63500" h="25400"/>
+          </a:sp3d>
+        </a:effectStyle>
+      </a:effectStyleLst>
+      <a:bgFillStyleLst>
+        <a:solidFill>
+          <a:schemeClr val="phClr"/>
+        </a:solidFill>
+        <a:gradFill rotWithShape="1">
+          <a:gsLst>
+            <a:gs pos="0">
+              <a:schemeClr val="phClr">
+                <a:tint val="40000"/>
+                <a:satMod val="350000"/>
+              </a:schemeClr>
+            </a:gs>
+            <a:gs pos="40000">
+              <a:schemeClr val="phClr">
+                <a:tint val="45000"/>
+                <a:shade val="99000"/>
+                <a:satMod val="350000"/>
+              </a:schemeClr>
+            </a:gs>
+            <a:gs pos="100000">
+              <a:schemeClr val="phClr">
+                <a:shade val="20000"/>
+                <a:satMod val="255000"/>
+              </a:schemeClr>
+            </a:gs>
+          </a:gsLst>
+          <a:path path="circle">
+            <a:fillToRect l="50000" t="-80000" r="50000" b="180000"/>
+          </a:path>
+        </a:gradFill>
+        <a:gradFill rotWithShape="1">
+          <a:gsLst>
+            <a:gs pos="0">
+              <a:schemeClr val="phClr">
+                <a:tint val="80000"/>
+                <a:satMod val="300000"/>
+              </a:schemeClr>
+            </a:gs>
+            <a:gs pos="100000">
+              <a:schemeClr val="phClr">
+                <a:shade val="30000"/>
+                <a:satMod val="200000"/>
+              </a:schemeClr>
+            </a:gs>
+          </a:gsLst>
+          <a:path path="circle">
+            <a:fillToRect l="50000" t="50000" r="50000" b="50000"/>
+          </a:path>
+        </a:gradFill>
+      </a:bgFillStyleLst>
+    </a:fmtScheme>
+  </a:themeElements>
+  <a:objectDefaults>
+    <a:spDef>
+      <a:spPr/>
+      <a:bodyPr/>
+      <a:lstStyle/>
+      <a:style>
+        <a:lnRef idx="1">
+          <a:schemeClr val="accent1"/>
+        </a:lnRef>
+        <a:fillRef idx="3">
+          <a:schemeClr val="accent1"/>
+        </a:fillRef>
+        <a:effectRef idx="2">
+          <a:schemeClr val="accent1"/>
+        </a:effectRef>
+        <a:fontRef idx="minor">
+          <a:schemeClr val="lt1"/>
+        </a:fontRef>
+      </a:style>
+    </a:spDef>
+    <a:lnDef>
+      <a:spPr/>
+      <a:bodyPr/>
+      <a:lstStyle/>
+      <a:style>
+        <a:lnRef idx="2">
+          <a:schemeClr val="accent1"/>
+        </a:lnRef>
+        <a:fillRef idx="0">
+          <a:schemeClr val="accent1"/>
+        </a:fillRef>
+        <a:effectRef idx="1">
+          <a:schemeClr val="accent1"/>
+        </a:effectRef>
+        <a:fontRef idx="minor">
+          <a:schemeClr val="tx1"/>
+        </a:fontRef>
+      </a:style>
+    </a:lnDef>
+  </a:objectDefaults>
+  <a:extraClrSchemeLst/>
+</a:theme>
 </file>
</xml_diff>